<commit_message>
Fix PubMed PDF and normalize PPTX exports
</commit_message>
<xml_diff>
--- a/archive/2026-06-02/pubmed-dlbcl-cnsl-btki-2026-06-02.pptx
+++ b/archive/2026-06-02/pubmed-dlbcl-cnsl-btki-2026-06-02.pptx
@@ -5,23 +5,23 @@
     <p:sldMasterId id="2147483648" r:id="rId1"/>
   </p:sldMasterIdLst>
   <p:sldIdLst>
-    <p:sldId id="256" r:id="rId7"/>
-    <p:sldId id="257" r:id="rId8"/>
-    <p:sldId id="258" r:id="rId9"/>
-    <p:sldId id="259" r:id="rId10"/>
-    <p:sldId id="260" r:id="rId11"/>
-    <p:sldId id="261" r:id="rId12"/>
-    <p:sldId id="262" r:id="rId13"/>
-    <p:sldId id="263" r:id="rId14"/>
-    <p:sldId id="264" r:id="rId15"/>
-    <p:sldId id="265" r:id="rId16"/>
-    <p:sldId id="266" r:id="rId17"/>
-    <p:sldId id="267" r:id="rId18"/>
-    <p:sldId id="268" r:id="rId19"/>
-    <p:sldId id="269" r:id="rId20"/>
-    <p:sldId id="270" r:id="rId21"/>
+    <p:sldId id="256" r:id="rId2"/>
+    <p:sldId id="257" r:id="rId3"/>
+    <p:sldId id="258" r:id="rId4"/>
+    <p:sldId id="259" r:id="rId5"/>
+    <p:sldId id="260" r:id="rId6"/>
+    <p:sldId id="261" r:id="rId7"/>
+    <p:sldId id="262" r:id="rId8"/>
+    <p:sldId id="263" r:id="rId9"/>
+    <p:sldId id="264" r:id="rId10"/>
+    <p:sldId id="265" r:id="rId11"/>
+    <p:sldId id="266" r:id="rId12"/>
+    <p:sldId id="267" r:id="rId13"/>
+    <p:sldId id="268" r:id="rId14"/>
+    <p:sldId id="269" r:id="rId15"/>
+    <p:sldId id="270" r:id="rId16"/>
   </p:sldIdLst>
-  <p:sldSz cx="12191695" cy="6858000" type="screen4x3"/>
+  <p:sldSz cx="12192000" cy="6858000"/>
   <p:notesSz cx="6858000" cy="9144000"/>
   <p:defaultTextStyle>
     <a:defPPr>
@@ -118,6 +118,22 @@
       </a:defRPr>
     </a:lvl9pPr>
   </p:defaultTextStyle>
+  <p:extLst>
+    <p:ext uri="{EFAFB233-063F-42B5-8137-9DF3F51BA10A}">
+      <p15:sldGuideLst xmlns:p15="http://schemas.microsoft.com/office/powerpoint/2012/main">
+        <p15:guide id="1" orient="horz" pos="2160">
+          <p15:clr>
+            <a:srgbClr val="A4A3A4"/>
+          </p15:clr>
+        </p15:guide>
+        <p15:guide id="2" pos="2880">
+          <p15:clr>
+            <a:srgbClr val="A4A3A4"/>
+          </p15:clr>
+        </p15:guide>
+      </p15:sldGuideLst>
+    </p:ext>
+  </p:extLst>
 </p:presentation>
 </file>
 
@@ -159,10 +175,9 @@
           <a:lstStyle/>
           <a:p>
             <a:r>
-              <a:rPr lang="en-US" smtClean="0"/>
+              <a:rPr lang="en-US"/>
               <a:t>Click to edit Master title style</a:t>
             </a:r>
-            <a:endParaRPr lang="en-US"/>
           </a:p>
         </p:txBody>
       </p:sp>
@@ -278,10 +293,9 @@
           </a:lstStyle>
           <a:p>
             <a:r>
-              <a:rPr lang="en-US" smtClean="0"/>
+              <a:rPr lang="en-US"/>
               <a:t>Click to edit Master subtitle style</a:t>
             </a:r>
-            <a:endParaRPr lang="en-US"/>
           </a:p>
         </p:txBody>
       </p:sp>
@@ -302,7 +316,7 @@
           <a:p>
             <a:fld id="{5BCAD085-E8A6-8845-BD4E-CB4CCA059FC4}" type="datetimeFigureOut">
               <a:rPr lang="en-US" smtClean="0"/>
-              <a:t>1/27/13</a:t>
+              <a:t>6/2/2026</a:t>
             </a:fld>
             <a:endParaRPr lang="en-US"/>
           </a:p>
@@ -396,10 +410,9 @@
           <a:lstStyle/>
           <a:p>
             <a:r>
-              <a:rPr lang="en-US" smtClean="0"/>
+              <a:rPr lang="en-US"/>
               <a:t>Click to edit Master title style</a:t>
             </a:r>
-            <a:endParaRPr lang="en-US"/>
           </a:p>
         </p:txBody>
       </p:sp>
@@ -420,38 +433,37 @@
           <a:p>
             <a:pPr lvl="0"/>
             <a:r>
-              <a:rPr lang="en-US" smtClean="0"/>
+              <a:rPr lang="en-US"/>
               <a:t>Click to edit Master text styles</a:t>
             </a:r>
           </a:p>
           <a:p>
             <a:pPr lvl="1"/>
             <a:r>
-              <a:rPr lang="en-US" smtClean="0"/>
+              <a:rPr lang="en-US"/>
               <a:t>Second level</a:t>
             </a:r>
           </a:p>
           <a:p>
             <a:pPr lvl="2"/>
             <a:r>
-              <a:rPr lang="en-US" smtClean="0"/>
+              <a:rPr lang="en-US"/>
               <a:t>Third level</a:t>
             </a:r>
           </a:p>
           <a:p>
             <a:pPr lvl="3"/>
             <a:r>
-              <a:rPr lang="en-US" smtClean="0"/>
+              <a:rPr lang="en-US"/>
               <a:t>Fourth level</a:t>
             </a:r>
           </a:p>
           <a:p>
             <a:pPr lvl="4"/>
             <a:r>
-              <a:rPr lang="en-US" smtClean="0"/>
+              <a:rPr lang="en-US"/>
               <a:t>Fifth level</a:t>
             </a:r>
-            <a:endParaRPr lang="en-US"/>
           </a:p>
         </p:txBody>
       </p:sp>
@@ -472,7 +484,7 @@
           <a:p>
             <a:fld id="{5BCAD085-E8A6-8845-BD4E-CB4CCA059FC4}" type="datetimeFigureOut">
               <a:rPr lang="en-US" smtClean="0"/>
-              <a:t>1/27/13</a:t>
+              <a:t>6/2/2026</a:t>
             </a:fld>
             <a:endParaRPr lang="en-US"/>
           </a:p>
@@ -571,10 +583,9 @@
           <a:lstStyle/>
           <a:p>
             <a:r>
-              <a:rPr lang="en-US" smtClean="0"/>
+              <a:rPr lang="en-US"/>
               <a:t>Click to edit Master title style</a:t>
             </a:r>
-            <a:endParaRPr lang="en-US"/>
           </a:p>
         </p:txBody>
       </p:sp>
@@ -600,38 +611,37 @@
           <a:p>
             <a:pPr lvl="0"/>
             <a:r>
-              <a:rPr lang="en-US" smtClean="0"/>
+              <a:rPr lang="en-US"/>
               <a:t>Click to edit Master text styles</a:t>
             </a:r>
           </a:p>
           <a:p>
             <a:pPr lvl="1"/>
             <a:r>
-              <a:rPr lang="en-US" smtClean="0"/>
+              <a:rPr lang="en-US"/>
               <a:t>Second level</a:t>
             </a:r>
           </a:p>
           <a:p>
             <a:pPr lvl="2"/>
             <a:r>
-              <a:rPr lang="en-US" smtClean="0"/>
+              <a:rPr lang="en-US"/>
               <a:t>Third level</a:t>
             </a:r>
           </a:p>
           <a:p>
             <a:pPr lvl="3"/>
             <a:r>
-              <a:rPr lang="en-US" smtClean="0"/>
+              <a:rPr lang="en-US"/>
               <a:t>Fourth level</a:t>
             </a:r>
           </a:p>
           <a:p>
             <a:pPr lvl="4"/>
             <a:r>
-              <a:rPr lang="en-US" smtClean="0"/>
+              <a:rPr lang="en-US"/>
               <a:t>Fifth level</a:t>
             </a:r>
-            <a:endParaRPr lang="en-US"/>
           </a:p>
         </p:txBody>
       </p:sp>
@@ -652,7 +662,7 @@
           <a:p>
             <a:fld id="{5BCAD085-E8A6-8845-BD4E-CB4CCA059FC4}" type="datetimeFigureOut">
               <a:rPr lang="en-US" smtClean="0"/>
-              <a:t>1/27/13</a:t>
+              <a:t>6/2/2026</a:t>
             </a:fld>
             <a:endParaRPr lang="en-US"/>
           </a:p>
@@ -746,10 +756,9 @@
           <a:lstStyle/>
           <a:p>
             <a:r>
-              <a:rPr lang="en-US" smtClean="0"/>
+              <a:rPr lang="en-US"/>
               <a:t>Click to edit Master title style</a:t>
             </a:r>
-            <a:endParaRPr lang="en-US"/>
           </a:p>
         </p:txBody>
       </p:sp>
@@ -770,38 +779,37 @@
           <a:p>
             <a:pPr lvl="0"/>
             <a:r>
-              <a:rPr lang="en-US" smtClean="0"/>
+              <a:rPr lang="en-US"/>
               <a:t>Click to edit Master text styles</a:t>
             </a:r>
           </a:p>
           <a:p>
             <a:pPr lvl="1"/>
             <a:r>
-              <a:rPr lang="en-US" smtClean="0"/>
+              <a:rPr lang="en-US"/>
               <a:t>Second level</a:t>
             </a:r>
           </a:p>
           <a:p>
             <a:pPr lvl="2"/>
             <a:r>
-              <a:rPr lang="en-US" smtClean="0"/>
+              <a:rPr lang="en-US"/>
               <a:t>Third level</a:t>
             </a:r>
           </a:p>
           <a:p>
             <a:pPr lvl="3"/>
             <a:r>
-              <a:rPr lang="en-US" smtClean="0"/>
+              <a:rPr lang="en-US"/>
               <a:t>Fourth level</a:t>
             </a:r>
           </a:p>
           <a:p>
             <a:pPr lvl="4"/>
             <a:r>
-              <a:rPr lang="en-US" smtClean="0"/>
+              <a:rPr lang="en-US"/>
               <a:t>Fifth level</a:t>
             </a:r>
-            <a:endParaRPr lang="en-US"/>
           </a:p>
         </p:txBody>
       </p:sp>
@@ -822,7 +830,7 @@
           <a:p>
             <a:fld id="{5BCAD085-E8A6-8845-BD4E-CB4CCA059FC4}" type="datetimeFigureOut">
               <a:rPr lang="en-US" smtClean="0"/>
-              <a:t>1/27/13</a:t>
+              <a:t>6/2/2026</a:t>
             </a:fld>
             <a:endParaRPr lang="en-US"/>
           </a:p>
@@ -925,10 +933,9 @@
           </a:lstStyle>
           <a:p>
             <a:r>
-              <a:rPr lang="en-US" smtClean="0"/>
+              <a:rPr lang="en-US"/>
               <a:t>Click to edit Master title style</a:t>
             </a:r>
-            <a:endParaRPr lang="en-US"/>
           </a:p>
         </p:txBody>
       </p:sp>
@@ -1045,7 +1052,7 @@
           <a:p>
             <a:pPr lvl="0"/>
             <a:r>
-              <a:rPr lang="en-US" smtClean="0"/>
+              <a:rPr lang="en-US"/>
               <a:t>Click to edit Master text styles</a:t>
             </a:r>
           </a:p>
@@ -1068,7 +1075,7 @@
           <a:p>
             <a:fld id="{5BCAD085-E8A6-8845-BD4E-CB4CCA059FC4}" type="datetimeFigureOut">
               <a:rPr lang="en-US" smtClean="0"/>
-              <a:t>1/27/13</a:t>
+              <a:t>6/2/2026</a:t>
             </a:fld>
             <a:endParaRPr lang="en-US"/>
           </a:p>
@@ -1162,10 +1169,9 @@
           <a:lstStyle/>
           <a:p>
             <a:r>
-              <a:rPr lang="en-US" smtClean="0"/>
+              <a:rPr lang="en-US"/>
               <a:t>Click to edit Master title style</a:t>
             </a:r>
-            <a:endParaRPr lang="en-US"/>
           </a:p>
         </p:txBody>
       </p:sp>
@@ -1219,38 +1225,37 @@
           <a:p>
             <a:pPr lvl="0"/>
             <a:r>
-              <a:rPr lang="en-US" smtClean="0"/>
+              <a:rPr lang="en-US"/>
               <a:t>Click to edit Master text styles</a:t>
             </a:r>
           </a:p>
           <a:p>
             <a:pPr lvl="1"/>
             <a:r>
-              <a:rPr lang="en-US" smtClean="0"/>
+              <a:rPr lang="en-US"/>
               <a:t>Second level</a:t>
             </a:r>
           </a:p>
           <a:p>
             <a:pPr lvl="2"/>
             <a:r>
-              <a:rPr lang="en-US" smtClean="0"/>
+              <a:rPr lang="en-US"/>
               <a:t>Third level</a:t>
             </a:r>
           </a:p>
           <a:p>
             <a:pPr lvl="3"/>
             <a:r>
-              <a:rPr lang="en-US" smtClean="0"/>
+              <a:rPr lang="en-US"/>
               <a:t>Fourth level</a:t>
             </a:r>
           </a:p>
           <a:p>
             <a:pPr lvl="4"/>
             <a:r>
-              <a:rPr lang="en-US" smtClean="0"/>
+              <a:rPr lang="en-US"/>
               <a:t>Fifth level</a:t>
             </a:r>
-            <a:endParaRPr lang="en-US"/>
           </a:p>
         </p:txBody>
       </p:sp>
@@ -1304,38 +1309,37 @@
           <a:p>
             <a:pPr lvl="0"/>
             <a:r>
-              <a:rPr lang="en-US" smtClean="0"/>
+              <a:rPr lang="en-US"/>
               <a:t>Click to edit Master text styles</a:t>
             </a:r>
           </a:p>
           <a:p>
             <a:pPr lvl="1"/>
             <a:r>
-              <a:rPr lang="en-US" smtClean="0"/>
+              <a:rPr lang="en-US"/>
               <a:t>Second level</a:t>
             </a:r>
           </a:p>
           <a:p>
             <a:pPr lvl="2"/>
             <a:r>
-              <a:rPr lang="en-US" smtClean="0"/>
+              <a:rPr lang="en-US"/>
               <a:t>Third level</a:t>
             </a:r>
           </a:p>
           <a:p>
             <a:pPr lvl="3"/>
             <a:r>
-              <a:rPr lang="en-US" smtClean="0"/>
+              <a:rPr lang="en-US"/>
               <a:t>Fourth level</a:t>
             </a:r>
           </a:p>
           <a:p>
             <a:pPr lvl="4"/>
             <a:r>
-              <a:rPr lang="en-US" smtClean="0"/>
+              <a:rPr lang="en-US"/>
               <a:t>Fifth level</a:t>
             </a:r>
-            <a:endParaRPr lang="en-US"/>
           </a:p>
         </p:txBody>
       </p:sp>
@@ -1356,7 +1360,7 @@
           <a:p>
             <a:fld id="{5BCAD085-E8A6-8845-BD4E-CB4CCA059FC4}" type="datetimeFigureOut">
               <a:rPr lang="en-US" smtClean="0"/>
-              <a:t>1/27/13</a:t>
+              <a:t>6/2/2026</a:t>
             </a:fld>
             <a:endParaRPr lang="en-US"/>
           </a:p>
@@ -1454,10 +1458,9 @@
           </a:lstStyle>
           <a:p>
             <a:r>
-              <a:rPr lang="en-US" smtClean="0"/>
+              <a:rPr lang="en-US"/>
               <a:t>Click to edit Master title style</a:t>
             </a:r>
-            <a:endParaRPr lang="en-US"/>
           </a:p>
         </p:txBody>
       </p:sp>
@@ -1520,7 +1523,7 @@
           <a:p>
             <a:pPr lvl="0"/>
             <a:r>
-              <a:rPr lang="en-US" smtClean="0"/>
+              <a:rPr lang="en-US"/>
               <a:t>Click to edit Master text styles</a:t>
             </a:r>
           </a:p>
@@ -1576,38 +1579,37 @@
           <a:p>
             <a:pPr lvl="0"/>
             <a:r>
-              <a:rPr lang="en-US" smtClean="0"/>
+              <a:rPr lang="en-US"/>
               <a:t>Click to edit Master text styles</a:t>
             </a:r>
           </a:p>
           <a:p>
             <a:pPr lvl="1"/>
             <a:r>
-              <a:rPr lang="en-US" smtClean="0"/>
+              <a:rPr lang="en-US"/>
               <a:t>Second level</a:t>
             </a:r>
           </a:p>
           <a:p>
             <a:pPr lvl="2"/>
             <a:r>
-              <a:rPr lang="en-US" smtClean="0"/>
+              <a:rPr lang="en-US"/>
               <a:t>Third level</a:t>
             </a:r>
           </a:p>
           <a:p>
             <a:pPr lvl="3"/>
             <a:r>
-              <a:rPr lang="en-US" smtClean="0"/>
+              <a:rPr lang="en-US"/>
               <a:t>Fourth level</a:t>
             </a:r>
           </a:p>
           <a:p>
             <a:pPr lvl="4"/>
             <a:r>
-              <a:rPr lang="en-US" smtClean="0"/>
+              <a:rPr lang="en-US"/>
               <a:t>Fifth level</a:t>
             </a:r>
-            <a:endParaRPr lang="en-US"/>
           </a:p>
         </p:txBody>
       </p:sp>
@@ -1670,7 +1672,7 @@
           <a:p>
             <a:pPr lvl="0"/>
             <a:r>
-              <a:rPr lang="en-US" smtClean="0"/>
+              <a:rPr lang="en-US"/>
               <a:t>Click to edit Master text styles</a:t>
             </a:r>
           </a:p>
@@ -1726,38 +1728,37 @@
           <a:p>
             <a:pPr lvl="0"/>
             <a:r>
-              <a:rPr lang="en-US" smtClean="0"/>
+              <a:rPr lang="en-US"/>
               <a:t>Click to edit Master text styles</a:t>
             </a:r>
           </a:p>
           <a:p>
             <a:pPr lvl="1"/>
             <a:r>
-              <a:rPr lang="en-US" smtClean="0"/>
+              <a:rPr lang="en-US"/>
               <a:t>Second level</a:t>
             </a:r>
           </a:p>
           <a:p>
             <a:pPr lvl="2"/>
             <a:r>
-              <a:rPr lang="en-US" smtClean="0"/>
+              <a:rPr lang="en-US"/>
               <a:t>Third level</a:t>
             </a:r>
           </a:p>
           <a:p>
             <a:pPr lvl="3"/>
             <a:r>
-              <a:rPr lang="en-US" smtClean="0"/>
+              <a:rPr lang="en-US"/>
               <a:t>Fourth level</a:t>
             </a:r>
           </a:p>
           <a:p>
             <a:pPr lvl="4"/>
             <a:r>
-              <a:rPr lang="en-US" smtClean="0"/>
+              <a:rPr lang="en-US"/>
               <a:t>Fifth level</a:t>
             </a:r>
-            <a:endParaRPr lang="en-US"/>
           </a:p>
         </p:txBody>
       </p:sp>
@@ -1778,7 +1779,7 @@
           <a:p>
             <a:fld id="{5BCAD085-E8A6-8845-BD4E-CB4CCA059FC4}" type="datetimeFigureOut">
               <a:rPr lang="en-US" smtClean="0"/>
-              <a:t>1/27/13</a:t>
+              <a:t>6/2/2026</a:t>
             </a:fld>
             <a:endParaRPr lang="en-US"/>
           </a:p>
@@ -1872,10 +1873,9 @@
           <a:lstStyle/>
           <a:p>
             <a:r>
-              <a:rPr lang="en-US" smtClean="0"/>
+              <a:rPr lang="en-US"/>
               <a:t>Click to edit Master title style</a:t>
             </a:r>
-            <a:endParaRPr lang="en-US"/>
           </a:p>
         </p:txBody>
       </p:sp>
@@ -1896,7 +1896,7 @@
           <a:p>
             <a:fld id="{5BCAD085-E8A6-8845-BD4E-CB4CCA059FC4}" type="datetimeFigureOut">
               <a:rPr lang="en-US" smtClean="0"/>
-              <a:t>1/27/13</a:t>
+              <a:t>6/2/2026</a:t>
             </a:fld>
             <a:endParaRPr lang="en-US"/>
           </a:p>
@@ -1991,7 +1991,7 @@
           <a:p>
             <a:fld id="{5BCAD085-E8A6-8845-BD4E-CB4CCA059FC4}" type="datetimeFigureOut">
               <a:rPr lang="en-US" smtClean="0"/>
-              <a:t>1/27/13</a:t>
+              <a:t>6/2/2026</a:t>
             </a:fld>
             <a:endParaRPr lang="en-US"/>
           </a:p>
@@ -2094,10 +2094,9 @@
           </a:lstStyle>
           <a:p>
             <a:r>
-              <a:rPr lang="en-US" smtClean="0"/>
+              <a:rPr lang="en-US"/>
               <a:t>Click to edit Master title style</a:t>
             </a:r>
-            <a:endParaRPr lang="en-US"/>
           </a:p>
         </p:txBody>
       </p:sp>
@@ -2151,38 +2150,37 @@
           <a:p>
             <a:pPr lvl="0"/>
             <a:r>
-              <a:rPr lang="en-US" smtClean="0"/>
+              <a:rPr lang="en-US"/>
               <a:t>Click to edit Master text styles</a:t>
             </a:r>
           </a:p>
           <a:p>
             <a:pPr lvl="1"/>
             <a:r>
-              <a:rPr lang="en-US" smtClean="0"/>
+              <a:rPr lang="en-US"/>
               <a:t>Second level</a:t>
             </a:r>
           </a:p>
           <a:p>
             <a:pPr lvl="2"/>
             <a:r>
-              <a:rPr lang="en-US" smtClean="0"/>
+              <a:rPr lang="en-US"/>
               <a:t>Third level</a:t>
             </a:r>
           </a:p>
           <a:p>
             <a:pPr lvl="3"/>
             <a:r>
-              <a:rPr lang="en-US" smtClean="0"/>
+              <a:rPr lang="en-US"/>
               <a:t>Fourth level</a:t>
             </a:r>
           </a:p>
           <a:p>
             <a:pPr lvl="4"/>
             <a:r>
-              <a:rPr lang="en-US" smtClean="0"/>
+              <a:rPr lang="en-US"/>
               <a:t>Fifth level</a:t>
             </a:r>
-            <a:endParaRPr lang="en-US"/>
           </a:p>
         </p:txBody>
       </p:sp>
@@ -2245,7 +2243,7 @@
           <a:p>
             <a:pPr lvl="0"/>
             <a:r>
-              <a:rPr lang="en-US" smtClean="0"/>
+              <a:rPr lang="en-US"/>
               <a:t>Click to edit Master text styles</a:t>
             </a:r>
           </a:p>
@@ -2268,7 +2266,7 @@
           <a:p>
             <a:fld id="{5BCAD085-E8A6-8845-BD4E-CB4CCA059FC4}" type="datetimeFigureOut">
               <a:rPr lang="en-US" smtClean="0"/>
-              <a:t>1/27/13</a:t>
+              <a:t>6/2/2026</a:t>
             </a:fld>
             <a:endParaRPr lang="en-US"/>
           </a:p>
@@ -2371,10 +2369,9 @@
           </a:lstStyle>
           <a:p>
             <a:r>
-              <a:rPr lang="en-US" smtClean="0"/>
+              <a:rPr lang="en-US"/>
               <a:t>Click to edit Master title style</a:t>
             </a:r>
-            <a:endParaRPr lang="en-US"/>
           </a:p>
         </p:txBody>
       </p:sp>
@@ -2498,7 +2495,7 @@
           <a:p>
             <a:pPr lvl="0"/>
             <a:r>
-              <a:rPr lang="en-US" smtClean="0"/>
+              <a:rPr lang="en-US"/>
               <a:t>Click to edit Master text styles</a:t>
             </a:r>
           </a:p>
@@ -2521,7 +2518,7 @@
           <a:p>
             <a:fld id="{5BCAD085-E8A6-8845-BD4E-CB4CCA059FC4}" type="datetimeFigureOut">
               <a:rPr lang="en-US" smtClean="0"/>
-              <a:t>1/27/13</a:t>
+              <a:t>6/2/2026</a:t>
             </a:fld>
             <a:endParaRPr lang="en-US"/>
           </a:p>
@@ -2630,10 +2627,9 @@
           <a:lstStyle/>
           <a:p>
             <a:r>
-              <a:rPr lang="en-US" smtClean="0"/>
+              <a:rPr lang="en-US"/>
               <a:t>Click to edit Master title style</a:t>
             </a:r>
-            <a:endParaRPr lang="en-US"/>
           </a:p>
         </p:txBody>
       </p:sp>
@@ -2664,38 +2660,37 @@
           <a:p>
             <a:pPr lvl="0"/>
             <a:r>
-              <a:rPr lang="en-US" smtClean="0"/>
+              <a:rPr lang="en-US"/>
               <a:t>Click to edit Master text styles</a:t>
             </a:r>
           </a:p>
           <a:p>
             <a:pPr lvl="1"/>
             <a:r>
-              <a:rPr lang="en-US" smtClean="0"/>
+              <a:rPr lang="en-US"/>
               <a:t>Second level</a:t>
             </a:r>
           </a:p>
           <a:p>
             <a:pPr lvl="2"/>
             <a:r>
-              <a:rPr lang="en-US" smtClean="0"/>
+              <a:rPr lang="en-US"/>
               <a:t>Third level</a:t>
             </a:r>
           </a:p>
           <a:p>
             <a:pPr lvl="3"/>
             <a:r>
-              <a:rPr lang="en-US" smtClean="0"/>
+              <a:rPr lang="en-US"/>
               <a:t>Fourth level</a:t>
             </a:r>
           </a:p>
           <a:p>
             <a:pPr lvl="4"/>
             <a:r>
-              <a:rPr lang="en-US" smtClean="0"/>
+              <a:rPr lang="en-US"/>
               <a:t>Fifth level</a:t>
             </a:r>
-            <a:endParaRPr lang="en-US"/>
           </a:p>
         </p:txBody>
       </p:sp>
@@ -2734,7 +2729,7 @@
           <a:p>
             <a:fld id="{5BCAD085-E8A6-8845-BD4E-CB4CCA059FC4}" type="datetimeFigureOut">
               <a:rPr lang="en-US" smtClean="0"/>
-              <a:t>1/27/13</a:t>
+              <a:t>6/2/2026</a:t>
             </a:fld>
             <a:endParaRPr lang="en-US"/>
           </a:p>
@@ -3093,7 +3088,7 @@
 </file>
 
 <file path=ppt/slides/slide1.xml><?xml version="1.0" encoding="utf-8"?>
-<p:sld xmlns:a="http://schemas.openxmlformats.org/drawingml/2006/main" xmlns:p="http://schemas.openxmlformats.org/presentationml/2006/main" xmlns:r="http://schemas.openxmlformats.org/officeDocument/2006/relationships">
+<p:sld xmlns:a="http://schemas.openxmlformats.org/drawingml/2006/main" xmlns:r="http://schemas.openxmlformats.org/officeDocument/2006/relationships" xmlns:p="http://schemas.openxmlformats.org/presentationml/2006/main">
   <p:cSld>
     <p:bg>
       <p:bgPr>
@@ -3109,7 +3104,14 @@
         <p:cNvGrpSpPr/>
         <p:nvPr/>
       </p:nvGrpSpPr>
-      <p:grpSpPr/>
+      <p:grpSpPr>
+        <a:xfrm>
+          <a:off x="0" y="0"/>
+          <a:ext cx="0" cy="0"/>
+          <a:chOff x="0" y="0"/>
+          <a:chExt cx="0" cy="0"/>
+        </a:xfrm>
+      </p:grpSpPr>
       <p:sp>
         <p:nvSpPr>
           <p:cNvPr id="2" name="TextBox 1"/>
@@ -3127,7 +3129,7 @@
           <a:noFill/>
         </p:spPr>
         <p:txBody>
-          <a:bodyPr wrap="square" lIns="45720" rIns="45720" tIns="27432" bIns="27432" anchor="t">
+          <a:bodyPr wrap="square" lIns="45720" tIns="27432" rIns="45720" bIns="27432" anchor="t">
             <a:spAutoFit/>
           </a:bodyPr>
           <a:lstStyle/>
@@ -3162,7 +3164,7 @@
           <a:noFill/>
         </p:spPr>
         <p:txBody>
-          <a:bodyPr wrap="square" lIns="45720" rIns="45720" tIns="27432" bIns="27432" anchor="t">
+          <a:bodyPr wrap="square" lIns="45720" tIns="27432" rIns="45720" bIns="27432" anchor="t">
             <a:spAutoFit/>
           </a:bodyPr>
           <a:lstStyle/>
@@ -3218,7 +3220,7 @@
           </a:fontRef>
         </p:style>
         <p:txBody>
-          <a:bodyPr rtlCol="0" anchor="ctr" lIns="146304" rIns="146304" tIns="91440" bIns="73152"/>
+          <a:bodyPr lIns="146304" tIns="91440" rIns="146304" bIns="73152" rtlCol="0" anchor="ctr"/>
           <a:lstStyle/>
           <a:p>
             <a:pPr algn="ctr"/>
@@ -3288,7 +3290,7 @@
           </a:fontRef>
         </p:style>
         <p:txBody>
-          <a:bodyPr rtlCol="0" anchor="ctr" wrap="square" lIns="164592" rIns="164592" tIns="109728" bIns="91440"/>
+          <a:bodyPr wrap="square" lIns="164592" tIns="109728" rIns="164592" bIns="91440" rtlCol="0" anchor="ctr"/>
           <a:lstStyle/>
           <a:p>
             <a:pPr algn="ctr"/>
@@ -3390,7 +3392,7 @@
           </a:fontRef>
         </p:style>
         <p:txBody>
-          <a:bodyPr rtlCol="0" anchor="ctr" wrap="square" lIns="164592" rIns="164592" tIns="109728" bIns="91440"/>
+          <a:bodyPr wrap="square" lIns="164592" tIns="109728" rIns="164592" bIns="91440" rtlCol="0" anchor="ctr"/>
           <a:lstStyle/>
           <a:p>
             <a:pPr algn="ctr"/>
@@ -3479,7 +3481,7 @@
 </file>
 
 <file path=ppt/slides/slide10.xml><?xml version="1.0" encoding="utf-8"?>
-<p:sld xmlns:a="http://schemas.openxmlformats.org/drawingml/2006/main" xmlns:p="http://schemas.openxmlformats.org/presentationml/2006/main" xmlns:r="http://schemas.openxmlformats.org/officeDocument/2006/relationships">
+<p:sld xmlns:a="http://schemas.openxmlformats.org/drawingml/2006/main" xmlns:r="http://schemas.openxmlformats.org/officeDocument/2006/relationships" xmlns:p="http://schemas.openxmlformats.org/presentationml/2006/main">
   <p:cSld>
     <p:bg>
       <p:bgPr>
@@ -3495,7 +3497,14 @@
         <p:cNvGrpSpPr/>
         <p:nvPr/>
       </p:nvGrpSpPr>
-      <p:grpSpPr/>
+      <p:grpSpPr>
+        <a:xfrm>
+          <a:off x="0" y="0"/>
+          <a:ext cx="0" cy="0"/>
+          <a:chOff x="0" y="0"/>
+          <a:chExt cx="0" cy="0"/>
+        </a:xfrm>
+      </p:grpSpPr>
       <p:sp>
         <p:nvSpPr>
           <p:cNvPr id="2" name="TextBox 1"/>
@@ -3513,7 +3522,7 @@
           <a:noFill/>
         </p:spPr>
         <p:txBody>
-          <a:bodyPr wrap="square" lIns="45720" rIns="45720" tIns="27432" bIns="27432" anchor="t">
+          <a:bodyPr wrap="square" lIns="45720" tIns="27432" rIns="45720" bIns="27432" anchor="t">
             <a:spAutoFit/>
           </a:bodyPr>
           <a:lstStyle/>
@@ -3548,7 +3557,7 @@
           <a:noFill/>
         </p:spPr>
         <p:txBody>
-          <a:bodyPr wrap="square" lIns="45720" rIns="45720" tIns="27432" bIns="27432" anchor="t">
+          <a:bodyPr wrap="square" lIns="45720" tIns="27432" rIns="45720" bIns="27432" anchor="t">
             <a:spAutoFit/>
           </a:bodyPr>
           <a:lstStyle/>
@@ -3583,7 +3592,7 @@
           <a:noFill/>
         </p:spPr>
         <p:txBody>
-          <a:bodyPr wrap="square" lIns="45720" rIns="45720" tIns="27432" bIns="27432" anchor="t">
+          <a:bodyPr wrap="square" lIns="45720" tIns="27432" rIns="45720" bIns="27432" anchor="t">
             <a:spAutoFit/>
           </a:bodyPr>
           <a:lstStyle/>
@@ -3639,7 +3648,7 @@
           </a:fontRef>
         </p:style>
         <p:txBody>
-          <a:bodyPr rtlCol="0" anchor="ctr" wrap="square" lIns="164592" rIns="164592" tIns="109728" bIns="91440"/>
+          <a:bodyPr wrap="square" lIns="164592" tIns="109728" rIns="164592" bIns="91440" rtlCol="0" anchor="ctr"/>
           <a:lstStyle/>
           <a:p>
             <a:pPr algn="ctr"/>
@@ -3757,7 +3766,7 @@
           </a:fontRef>
         </p:style>
         <p:txBody>
-          <a:bodyPr rtlCol="0" anchor="ctr" lIns="146304" rIns="146304" tIns="91440" bIns="73152"/>
+          <a:bodyPr lIns="146304" tIns="91440" rIns="146304" bIns="73152" rtlCol="0" anchor="ctr"/>
           <a:lstStyle/>
           <a:p>
             <a:pPr algn="ctr"/>
@@ -3790,7 +3799,7 @@
           <a:noFill/>
         </p:spPr>
         <p:txBody>
-          <a:bodyPr wrap="square" lIns="45720" rIns="45720" tIns="27432" bIns="27432" anchor="t">
+          <a:bodyPr wrap="square" lIns="45720" tIns="27432" rIns="45720" bIns="27432" anchor="t">
             <a:spAutoFit/>
           </a:bodyPr>
           <a:lstStyle/>
@@ -3825,7 +3834,7 @@
           <a:noFill/>
         </p:spPr>
         <p:txBody>
-          <a:bodyPr wrap="square" lIns="45720" rIns="45720" tIns="27432" bIns="27432" anchor="t">
+          <a:bodyPr wrap="square" lIns="45720" tIns="27432" rIns="45720" bIns="27432" anchor="t">
             <a:spAutoFit/>
           </a:bodyPr>
           <a:lstStyle/>
@@ -3860,7 +3869,7 @@
           <a:noFill/>
         </p:spPr>
         <p:txBody>
-          <a:bodyPr wrap="square" lIns="45720" rIns="45720" tIns="27432" bIns="27432" anchor="t">
+          <a:bodyPr wrap="square" lIns="45720" tIns="27432" rIns="45720" bIns="27432" anchor="t">
             <a:spAutoFit/>
           </a:bodyPr>
           <a:lstStyle/>
@@ -3895,7 +3904,7 @@
           <a:noFill/>
         </p:spPr>
         <p:txBody>
-          <a:bodyPr wrap="square" lIns="45720" rIns="45720" tIns="27432" bIns="27432" anchor="t">
+          <a:bodyPr wrap="square" lIns="45720" tIns="27432" rIns="45720" bIns="27432" anchor="t">
             <a:spAutoFit/>
           </a:bodyPr>
           <a:lstStyle/>
@@ -3930,7 +3939,7 @@
           <a:noFill/>
         </p:spPr>
         <p:txBody>
-          <a:bodyPr wrap="square" lIns="45720" rIns="45720" tIns="27432" bIns="27432" anchor="t">
+          <a:bodyPr wrap="square" lIns="45720" tIns="27432" rIns="45720" bIns="27432" anchor="t">
             <a:spAutoFit/>
           </a:bodyPr>
           <a:lstStyle/>
@@ -3965,7 +3974,7 @@
           <a:noFill/>
         </p:spPr>
         <p:txBody>
-          <a:bodyPr wrap="square" lIns="45720" rIns="45720" tIns="27432" bIns="27432" anchor="t">
+          <a:bodyPr wrap="square" lIns="45720" tIns="27432" rIns="45720" bIns="27432" anchor="t">
             <a:spAutoFit/>
           </a:bodyPr>
           <a:lstStyle/>
@@ -4000,7 +4009,7 @@
           <a:noFill/>
         </p:spPr>
         <p:txBody>
-          <a:bodyPr wrap="square" lIns="45720" rIns="45720" tIns="27432" bIns="27432" anchor="t">
+          <a:bodyPr wrap="square" lIns="45720" tIns="27432" rIns="45720" bIns="27432" anchor="t">
             <a:spAutoFit/>
           </a:bodyPr>
           <a:lstStyle/>
@@ -4035,7 +4044,7 @@
           <a:noFill/>
         </p:spPr>
         <p:txBody>
-          <a:bodyPr wrap="square" lIns="45720" rIns="45720" tIns="27432" bIns="27432" anchor="t">
+          <a:bodyPr wrap="square" lIns="45720" tIns="27432" rIns="45720" bIns="27432" anchor="t">
             <a:spAutoFit/>
           </a:bodyPr>
           <a:lstStyle/>
@@ -4091,7 +4100,7 @@
           </a:fontRef>
         </p:style>
         <p:txBody>
-          <a:bodyPr rtlCol="0" anchor="ctr" lIns="146304" rIns="146304" tIns="91440" bIns="73152"/>
+          <a:bodyPr lIns="146304" tIns="91440" rIns="146304" bIns="73152" rtlCol="0" anchor="ctr"/>
           <a:lstStyle/>
           <a:p>
             <a:pPr algn="ctr"/>
@@ -4124,7 +4133,7 @@
           <a:noFill/>
         </p:spPr>
         <p:txBody>
-          <a:bodyPr wrap="square" lIns="45720" rIns="45720" tIns="27432" bIns="27432" anchor="t">
+          <a:bodyPr wrap="square" lIns="45720" tIns="27432" rIns="45720" bIns="27432" anchor="t">
             <a:spAutoFit/>
           </a:bodyPr>
           <a:lstStyle/>
@@ -4184,6 +4193,7 @@
           <a:lstStyle/>
           <a:p>
             <a:pPr algn="ctr"/>
+            <a:endParaRPr/>
           </a:p>
         </p:txBody>
       </p:sp>
@@ -4229,6 +4239,7 @@
           <a:lstStyle/>
           <a:p>
             <a:pPr algn="ctr"/>
+            <a:endParaRPr/>
           </a:p>
         </p:txBody>
       </p:sp>
@@ -4249,7 +4260,7 @@
           <a:noFill/>
         </p:spPr>
         <p:txBody>
-          <a:bodyPr wrap="square" lIns="45720" rIns="45720" tIns="27432" bIns="27432" anchor="t">
+          <a:bodyPr wrap="square" lIns="45720" tIns="27432" rIns="45720" bIns="27432" anchor="t">
             <a:spAutoFit/>
           </a:bodyPr>
           <a:lstStyle/>
@@ -4284,7 +4295,7 @@
           <a:noFill/>
         </p:spPr>
         <p:txBody>
-          <a:bodyPr wrap="square" lIns="45720" rIns="45720" tIns="27432" bIns="27432" anchor="t">
+          <a:bodyPr wrap="square" lIns="45720" tIns="27432" rIns="45720" bIns="27432" anchor="t">
             <a:spAutoFit/>
           </a:bodyPr>
           <a:lstStyle/>
@@ -4344,6 +4355,7 @@
           <a:lstStyle/>
           <a:p>
             <a:pPr algn="ctr"/>
+            <a:endParaRPr/>
           </a:p>
         </p:txBody>
       </p:sp>
@@ -4389,6 +4401,7 @@
           <a:lstStyle/>
           <a:p>
             <a:pPr algn="ctr"/>
+            <a:endParaRPr/>
           </a:p>
         </p:txBody>
       </p:sp>
@@ -4409,7 +4422,7 @@
           <a:noFill/>
         </p:spPr>
         <p:txBody>
-          <a:bodyPr wrap="square" lIns="45720" rIns="45720" tIns="27432" bIns="27432" anchor="t">
+          <a:bodyPr wrap="square" lIns="45720" tIns="27432" rIns="45720" bIns="27432" anchor="t">
             <a:spAutoFit/>
           </a:bodyPr>
           <a:lstStyle/>
@@ -4444,7 +4457,7 @@
           <a:noFill/>
         </p:spPr>
         <p:txBody>
-          <a:bodyPr wrap="square" lIns="45720" rIns="45720" tIns="27432" bIns="27432" anchor="t">
+          <a:bodyPr wrap="square" lIns="45720" tIns="27432" rIns="45720" bIns="27432" anchor="t">
             <a:spAutoFit/>
           </a:bodyPr>
           <a:lstStyle/>
@@ -4504,6 +4517,7 @@
           <a:lstStyle/>
           <a:p>
             <a:pPr algn="ctr"/>
+            <a:endParaRPr/>
           </a:p>
         </p:txBody>
       </p:sp>
@@ -4549,6 +4563,7 @@
           <a:lstStyle/>
           <a:p>
             <a:pPr algn="ctr"/>
+            <a:endParaRPr/>
           </a:p>
         </p:txBody>
       </p:sp>
@@ -4569,7 +4584,7 @@
           <a:noFill/>
         </p:spPr>
         <p:txBody>
-          <a:bodyPr wrap="square" lIns="45720" rIns="45720" tIns="27432" bIns="27432" anchor="t">
+          <a:bodyPr wrap="square" lIns="45720" tIns="27432" rIns="45720" bIns="27432" anchor="t">
             <a:spAutoFit/>
           </a:bodyPr>
           <a:lstStyle/>
@@ -4604,7 +4619,7 @@
           <a:noFill/>
         </p:spPr>
         <p:txBody>
-          <a:bodyPr wrap="square" lIns="45720" rIns="45720" tIns="27432" bIns="27432" anchor="t">
+          <a:bodyPr wrap="square" lIns="45720" tIns="27432" rIns="45720" bIns="27432" anchor="t">
             <a:spAutoFit/>
           </a:bodyPr>
           <a:lstStyle/>
@@ -4664,6 +4679,7 @@
           <a:lstStyle/>
           <a:p>
             <a:pPr algn="ctr"/>
+            <a:endParaRPr/>
           </a:p>
         </p:txBody>
       </p:sp>
@@ -4709,6 +4725,7 @@
           <a:lstStyle/>
           <a:p>
             <a:pPr algn="ctr"/>
+            <a:endParaRPr/>
           </a:p>
         </p:txBody>
       </p:sp>
@@ -4729,7 +4746,7 @@
           <a:noFill/>
         </p:spPr>
         <p:txBody>
-          <a:bodyPr wrap="square" lIns="45720" rIns="45720" tIns="27432" bIns="27432" anchor="t">
+          <a:bodyPr wrap="square" lIns="45720" tIns="27432" rIns="45720" bIns="27432" anchor="t">
             <a:spAutoFit/>
           </a:bodyPr>
           <a:lstStyle/>
@@ -4785,7 +4802,7 @@
           </a:fontRef>
         </p:style>
         <p:txBody>
-          <a:bodyPr rtlCol="0" anchor="ctr" lIns="146304" rIns="146304" tIns="91440" bIns="73152"/>
+          <a:bodyPr lIns="146304" tIns="91440" rIns="146304" bIns="73152" rtlCol="0" anchor="ctr"/>
           <a:lstStyle/>
           <a:p>
             <a:pPr algn="ctr"/>
@@ -4826,7 +4843,7 @@
 </file>
 
 <file path=ppt/slides/slide11.xml><?xml version="1.0" encoding="utf-8"?>
-<p:sld xmlns:a="http://schemas.openxmlformats.org/drawingml/2006/main" xmlns:p="http://schemas.openxmlformats.org/presentationml/2006/main" xmlns:r="http://schemas.openxmlformats.org/officeDocument/2006/relationships">
+<p:sld xmlns:a="http://schemas.openxmlformats.org/drawingml/2006/main" xmlns:r="http://schemas.openxmlformats.org/officeDocument/2006/relationships" xmlns:p="http://schemas.openxmlformats.org/presentationml/2006/main">
   <p:cSld>
     <p:bg>
       <p:bgPr>
@@ -4842,7 +4859,14 @@
         <p:cNvGrpSpPr/>
         <p:nvPr/>
       </p:nvGrpSpPr>
-      <p:grpSpPr/>
+      <p:grpSpPr>
+        <a:xfrm>
+          <a:off x="0" y="0"/>
+          <a:ext cx="0" cy="0"/>
+          <a:chOff x="0" y="0"/>
+          <a:chExt cx="0" cy="0"/>
+        </a:xfrm>
+      </p:grpSpPr>
       <p:sp>
         <p:nvSpPr>
           <p:cNvPr id="2" name="TextBox 1"/>
@@ -4860,7 +4884,7 @@
           <a:noFill/>
         </p:spPr>
         <p:txBody>
-          <a:bodyPr wrap="square" lIns="45720" rIns="45720" tIns="27432" bIns="27432" anchor="t">
+          <a:bodyPr wrap="square" lIns="45720" tIns="27432" rIns="45720" bIns="27432" anchor="t">
             <a:spAutoFit/>
           </a:bodyPr>
           <a:lstStyle/>
@@ -4895,7 +4919,7 @@
           <a:noFill/>
         </p:spPr>
         <p:txBody>
-          <a:bodyPr wrap="square" lIns="45720" rIns="45720" tIns="27432" bIns="27432" anchor="t">
+          <a:bodyPr wrap="square" lIns="45720" tIns="27432" rIns="45720" bIns="27432" anchor="t">
             <a:spAutoFit/>
           </a:bodyPr>
           <a:lstStyle/>
@@ -4934,7 +4958,7 @@
           <a:noFill/>
         </p:spPr>
         <p:txBody>
-          <a:bodyPr wrap="square" lIns="45720" rIns="45720" tIns="27432" bIns="27432" anchor="t">
+          <a:bodyPr wrap="square" lIns="45720" tIns="27432" rIns="45720" bIns="27432" anchor="t">
             <a:spAutoFit/>
           </a:bodyPr>
           <a:lstStyle/>
@@ -4990,7 +5014,7 @@
           </a:fontRef>
         </p:style>
         <p:txBody>
-          <a:bodyPr rtlCol="0" anchor="ctr" lIns="146304" rIns="146304" tIns="91440" bIns="73152"/>
+          <a:bodyPr lIns="146304" tIns="91440" rIns="146304" bIns="73152" rtlCol="0" anchor="ctr"/>
           <a:lstStyle/>
           <a:p>
             <a:pPr algn="ctr"/>
@@ -5060,7 +5084,7 @@
           </a:fontRef>
         </p:style>
         <p:txBody>
-          <a:bodyPr rtlCol="0" anchor="ctr" lIns="146304" rIns="146304" tIns="91440" bIns="73152"/>
+          <a:bodyPr lIns="146304" tIns="91440" rIns="146304" bIns="73152" rtlCol="0" anchor="ctr"/>
           <a:lstStyle/>
           <a:p>
             <a:pPr algn="ctr"/>
@@ -5130,7 +5154,7 @@
           </a:fontRef>
         </p:style>
         <p:txBody>
-          <a:bodyPr rtlCol="0" anchor="ctr" wrap="square" lIns="164592" rIns="164592" tIns="109728" bIns="91440"/>
+          <a:bodyPr wrap="square" lIns="164592" tIns="109728" rIns="164592" bIns="91440" rtlCol="0" anchor="ctr"/>
           <a:lstStyle/>
           <a:p>
             <a:pPr algn="ctr"/>
@@ -5232,7 +5256,7 @@
           </a:fontRef>
         </p:style>
         <p:txBody>
-          <a:bodyPr rtlCol="0" anchor="ctr" wrap="square" lIns="164592" rIns="164592" tIns="109728" bIns="91440"/>
+          <a:bodyPr wrap="square" lIns="164592" tIns="109728" rIns="164592" bIns="91440" rtlCol="0" anchor="ctr"/>
           <a:lstStyle/>
           <a:p>
             <a:pPr algn="ctr"/>
@@ -5334,7 +5358,7 @@
           </a:fontRef>
         </p:style>
         <p:txBody>
-          <a:bodyPr rtlCol="0" anchor="ctr" wrap="square" lIns="164592" rIns="164592" tIns="109728" bIns="91440"/>
+          <a:bodyPr wrap="square" lIns="164592" tIns="109728" rIns="164592" bIns="91440" rtlCol="0" anchor="ctr"/>
           <a:lstStyle/>
           <a:p>
             <a:pPr algn="ctr"/>
@@ -5407,7 +5431,7 @@
 </file>
 
 <file path=ppt/slides/slide12.xml><?xml version="1.0" encoding="utf-8"?>
-<p:sld xmlns:a="http://schemas.openxmlformats.org/drawingml/2006/main" xmlns:p="http://schemas.openxmlformats.org/presentationml/2006/main" xmlns:r="http://schemas.openxmlformats.org/officeDocument/2006/relationships">
+<p:sld xmlns:a="http://schemas.openxmlformats.org/drawingml/2006/main" xmlns:r="http://schemas.openxmlformats.org/officeDocument/2006/relationships" xmlns:p="http://schemas.openxmlformats.org/presentationml/2006/main">
   <p:cSld>
     <p:bg>
       <p:bgPr>
@@ -5423,7 +5447,14 @@
         <p:cNvGrpSpPr/>
         <p:nvPr/>
       </p:nvGrpSpPr>
-      <p:grpSpPr/>
+      <p:grpSpPr>
+        <a:xfrm>
+          <a:off x="0" y="0"/>
+          <a:ext cx="0" cy="0"/>
+          <a:chOff x="0" y="0"/>
+          <a:chExt cx="0" cy="0"/>
+        </a:xfrm>
+      </p:grpSpPr>
       <p:sp>
         <p:nvSpPr>
           <p:cNvPr id="2" name="TextBox 1"/>
@@ -5441,7 +5472,7 @@
           <a:noFill/>
         </p:spPr>
         <p:txBody>
-          <a:bodyPr wrap="square" lIns="45720" rIns="45720" tIns="27432" bIns="27432" anchor="t">
+          <a:bodyPr wrap="square" lIns="45720" tIns="27432" rIns="45720" bIns="27432" anchor="t">
             <a:spAutoFit/>
           </a:bodyPr>
           <a:lstStyle/>
@@ -5476,7 +5507,7 @@
           <a:noFill/>
         </p:spPr>
         <p:txBody>
-          <a:bodyPr wrap="square" lIns="45720" rIns="45720" tIns="27432" bIns="27432" anchor="t">
+          <a:bodyPr wrap="square" lIns="45720" tIns="27432" rIns="45720" bIns="27432" anchor="t">
             <a:spAutoFit/>
           </a:bodyPr>
           <a:lstStyle/>
@@ -5511,7 +5542,7 @@
           <a:noFill/>
         </p:spPr>
         <p:txBody>
-          <a:bodyPr wrap="square" lIns="45720" rIns="45720" tIns="27432" bIns="27432" anchor="t">
+          <a:bodyPr wrap="square" lIns="45720" tIns="27432" rIns="45720" bIns="27432" anchor="t">
             <a:spAutoFit/>
           </a:bodyPr>
           <a:lstStyle/>
@@ -5567,7 +5598,7 @@
           </a:fontRef>
         </p:style>
         <p:txBody>
-          <a:bodyPr rtlCol="0" anchor="ctr" wrap="square" lIns="164592" rIns="164592" tIns="109728" bIns="91440"/>
+          <a:bodyPr wrap="square" lIns="164592" tIns="109728" rIns="164592" bIns="91440" rtlCol="0" anchor="ctr"/>
           <a:lstStyle/>
           <a:p>
             <a:pPr algn="ctr"/>
@@ -5685,7 +5716,7 @@
           </a:fontRef>
         </p:style>
         <p:txBody>
-          <a:bodyPr rtlCol="0" anchor="ctr" lIns="146304" rIns="146304" tIns="91440" bIns="73152"/>
+          <a:bodyPr lIns="146304" tIns="91440" rIns="146304" bIns="73152" rtlCol="0" anchor="ctr"/>
           <a:lstStyle/>
           <a:p>
             <a:pPr algn="ctr"/>
@@ -5718,7 +5749,7 @@
           <a:noFill/>
         </p:spPr>
         <p:txBody>
-          <a:bodyPr wrap="square" lIns="45720" rIns="45720" tIns="27432" bIns="27432" anchor="t">
+          <a:bodyPr wrap="square" lIns="45720" tIns="27432" rIns="45720" bIns="27432" anchor="t">
             <a:spAutoFit/>
           </a:bodyPr>
           <a:lstStyle/>
@@ -5753,7 +5784,7 @@
           <a:noFill/>
         </p:spPr>
         <p:txBody>
-          <a:bodyPr wrap="square" lIns="45720" rIns="45720" tIns="27432" bIns="27432" anchor="t">
+          <a:bodyPr wrap="square" lIns="45720" tIns="27432" rIns="45720" bIns="27432" anchor="t">
             <a:spAutoFit/>
           </a:bodyPr>
           <a:lstStyle/>
@@ -5788,7 +5819,7 @@
           <a:noFill/>
         </p:spPr>
         <p:txBody>
-          <a:bodyPr wrap="square" lIns="45720" rIns="45720" tIns="27432" bIns="27432" anchor="t">
+          <a:bodyPr wrap="square" lIns="45720" tIns="27432" rIns="45720" bIns="27432" anchor="t">
             <a:spAutoFit/>
           </a:bodyPr>
           <a:lstStyle/>
@@ -5823,7 +5854,7 @@
           <a:noFill/>
         </p:spPr>
         <p:txBody>
-          <a:bodyPr wrap="square" lIns="45720" rIns="45720" tIns="27432" bIns="27432" anchor="t">
+          <a:bodyPr wrap="square" lIns="45720" tIns="27432" rIns="45720" bIns="27432" anchor="t">
             <a:spAutoFit/>
           </a:bodyPr>
           <a:lstStyle/>
@@ -5858,7 +5889,7 @@
           <a:noFill/>
         </p:spPr>
         <p:txBody>
-          <a:bodyPr wrap="square" lIns="45720" rIns="45720" tIns="27432" bIns="27432" anchor="t">
+          <a:bodyPr wrap="square" lIns="45720" tIns="27432" rIns="45720" bIns="27432" anchor="t">
             <a:spAutoFit/>
           </a:bodyPr>
           <a:lstStyle/>
@@ -5893,7 +5924,7 @@
           <a:noFill/>
         </p:spPr>
         <p:txBody>
-          <a:bodyPr wrap="square" lIns="45720" rIns="45720" tIns="27432" bIns="27432" anchor="t">
+          <a:bodyPr wrap="square" lIns="45720" tIns="27432" rIns="45720" bIns="27432" anchor="t">
             <a:spAutoFit/>
           </a:bodyPr>
           <a:lstStyle/>
@@ -5928,7 +5959,7 @@
           <a:noFill/>
         </p:spPr>
         <p:txBody>
-          <a:bodyPr wrap="square" lIns="45720" rIns="45720" tIns="27432" bIns="27432" anchor="t">
+          <a:bodyPr wrap="square" lIns="45720" tIns="27432" rIns="45720" bIns="27432" anchor="t">
             <a:spAutoFit/>
           </a:bodyPr>
           <a:lstStyle/>
@@ -5963,7 +5994,7 @@
           <a:noFill/>
         </p:spPr>
         <p:txBody>
-          <a:bodyPr wrap="square" lIns="45720" rIns="45720" tIns="27432" bIns="27432" anchor="t">
+          <a:bodyPr wrap="square" lIns="45720" tIns="27432" rIns="45720" bIns="27432" anchor="t">
             <a:spAutoFit/>
           </a:bodyPr>
           <a:lstStyle/>
@@ -6019,7 +6050,7 @@
           </a:fontRef>
         </p:style>
         <p:txBody>
-          <a:bodyPr rtlCol="0" anchor="ctr" lIns="146304" rIns="146304" tIns="91440" bIns="73152"/>
+          <a:bodyPr lIns="146304" tIns="91440" rIns="146304" bIns="73152" rtlCol="0" anchor="ctr"/>
           <a:lstStyle/>
           <a:p>
             <a:pPr algn="ctr"/>
@@ -6052,7 +6083,7 @@
           <a:noFill/>
         </p:spPr>
         <p:txBody>
-          <a:bodyPr wrap="square" lIns="45720" rIns="45720" tIns="27432" bIns="27432" anchor="t">
+          <a:bodyPr wrap="square" lIns="45720" tIns="27432" rIns="45720" bIns="27432" anchor="t">
             <a:spAutoFit/>
           </a:bodyPr>
           <a:lstStyle/>
@@ -6112,6 +6143,7 @@
           <a:lstStyle/>
           <a:p>
             <a:pPr algn="ctr"/>
+            <a:endParaRPr/>
           </a:p>
         </p:txBody>
       </p:sp>
@@ -6157,6 +6189,7 @@
           <a:lstStyle/>
           <a:p>
             <a:pPr algn="ctr"/>
+            <a:endParaRPr/>
           </a:p>
         </p:txBody>
       </p:sp>
@@ -6177,7 +6210,7 @@
           <a:noFill/>
         </p:spPr>
         <p:txBody>
-          <a:bodyPr wrap="square" lIns="45720" rIns="45720" tIns="27432" bIns="27432" anchor="t">
+          <a:bodyPr wrap="square" lIns="45720" tIns="27432" rIns="45720" bIns="27432" anchor="t">
             <a:spAutoFit/>
           </a:bodyPr>
           <a:lstStyle/>
@@ -6212,7 +6245,7 @@
           <a:noFill/>
         </p:spPr>
         <p:txBody>
-          <a:bodyPr wrap="square" lIns="45720" rIns="45720" tIns="27432" bIns="27432" anchor="t">
+          <a:bodyPr wrap="square" lIns="45720" tIns="27432" rIns="45720" bIns="27432" anchor="t">
             <a:spAutoFit/>
           </a:bodyPr>
           <a:lstStyle/>
@@ -6272,6 +6305,7 @@
           <a:lstStyle/>
           <a:p>
             <a:pPr algn="ctr"/>
+            <a:endParaRPr/>
           </a:p>
         </p:txBody>
       </p:sp>
@@ -6317,6 +6351,7 @@
           <a:lstStyle/>
           <a:p>
             <a:pPr algn="ctr"/>
+            <a:endParaRPr/>
           </a:p>
         </p:txBody>
       </p:sp>
@@ -6337,7 +6372,7 @@
           <a:noFill/>
         </p:spPr>
         <p:txBody>
-          <a:bodyPr wrap="square" lIns="45720" rIns="45720" tIns="27432" bIns="27432" anchor="t">
+          <a:bodyPr wrap="square" lIns="45720" tIns="27432" rIns="45720" bIns="27432" anchor="t">
             <a:spAutoFit/>
           </a:bodyPr>
           <a:lstStyle/>
@@ -6372,7 +6407,7 @@
           <a:noFill/>
         </p:spPr>
         <p:txBody>
-          <a:bodyPr wrap="square" lIns="45720" rIns="45720" tIns="27432" bIns="27432" anchor="t">
+          <a:bodyPr wrap="square" lIns="45720" tIns="27432" rIns="45720" bIns="27432" anchor="t">
             <a:spAutoFit/>
           </a:bodyPr>
           <a:lstStyle/>
@@ -6432,6 +6467,7 @@
           <a:lstStyle/>
           <a:p>
             <a:pPr algn="ctr"/>
+            <a:endParaRPr/>
           </a:p>
         </p:txBody>
       </p:sp>
@@ -6477,6 +6513,7 @@
           <a:lstStyle/>
           <a:p>
             <a:pPr algn="ctr"/>
+            <a:endParaRPr/>
           </a:p>
         </p:txBody>
       </p:sp>
@@ -6497,7 +6534,7 @@
           <a:noFill/>
         </p:spPr>
         <p:txBody>
-          <a:bodyPr wrap="square" lIns="45720" rIns="45720" tIns="27432" bIns="27432" anchor="t">
+          <a:bodyPr wrap="square" lIns="45720" tIns="27432" rIns="45720" bIns="27432" anchor="t">
             <a:spAutoFit/>
           </a:bodyPr>
           <a:lstStyle/>
@@ -6532,7 +6569,7 @@
           <a:noFill/>
         </p:spPr>
         <p:txBody>
-          <a:bodyPr wrap="square" lIns="45720" rIns="45720" tIns="27432" bIns="27432" anchor="t">
+          <a:bodyPr wrap="square" lIns="45720" tIns="27432" rIns="45720" bIns="27432" anchor="t">
             <a:spAutoFit/>
           </a:bodyPr>
           <a:lstStyle/>
@@ -6592,6 +6629,7 @@
           <a:lstStyle/>
           <a:p>
             <a:pPr algn="ctr"/>
+            <a:endParaRPr/>
           </a:p>
         </p:txBody>
       </p:sp>
@@ -6637,6 +6675,7 @@
           <a:lstStyle/>
           <a:p>
             <a:pPr algn="ctr"/>
+            <a:endParaRPr/>
           </a:p>
         </p:txBody>
       </p:sp>
@@ -6657,7 +6696,7 @@
           <a:noFill/>
         </p:spPr>
         <p:txBody>
-          <a:bodyPr wrap="square" lIns="45720" rIns="45720" tIns="27432" bIns="27432" anchor="t">
+          <a:bodyPr wrap="square" lIns="45720" tIns="27432" rIns="45720" bIns="27432" anchor="t">
             <a:spAutoFit/>
           </a:bodyPr>
           <a:lstStyle/>
@@ -6713,7 +6752,7 @@
           </a:fontRef>
         </p:style>
         <p:txBody>
-          <a:bodyPr rtlCol="0" anchor="ctr" lIns="146304" rIns="146304" tIns="91440" bIns="73152"/>
+          <a:bodyPr lIns="146304" tIns="91440" rIns="146304" bIns="73152" rtlCol="0" anchor="ctr"/>
           <a:lstStyle/>
           <a:p>
             <a:pPr algn="ctr"/>
@@ -6746,7 +6785,7 @@
           <a:noFill/>
         </p:spPr>
         <p:txBody>
-          <a:bodyPr wrap="square" lIns="45720" rIns="45720" tIns="27432" bIns="27432" anchor="t">
+          <a:bodyPr wrap="square" lIns="45720" tIns="27432" rIns="45720" bIns="27432" anchor="t">
             <a:spAutoFit/>
           </a:bodyPr>
           <a:lstStyle/>
@@ -6806,6 +6845,7 @@
           <a:lstStyle/>
           <a:p>
             <a:pPr algn="ctr"/>
+            <a:endParaRPr/>
           </a:p>
         </p:txBody>
       </p:sp>
@@ -6851,6 +6891,7 @@
           <a:lstStyle/>
           <a:p>
             <a:pPr algn="ctr"/>
+            <a:endParaRPr/>
           </a:p>
         </p:txBody>
       </p:sp>
@@ -6871,7 +6912,7 @@
           <a:noFill/>
         </p:spPr>
         <p:txBody>
-          <a:bodyPr wrap="square" lIns="45720" rIns="45720" tIns="27432" bIns="27432" anchor="t">
+          <a:bodyPr wrap="square" lIns="45720" tIns="27432" rIns="45720" bIns="27432" anchor="t">
             <a:spAutoFit/>
           </a:bodyPr>
           <a:lstStyle/>
@@ -6906,7 +6947,7 @@
           <a:noFill/>
         </p:spPr>
         <p:txBody>
-          <a:bodyPr wrap="square" lIns="45720" rIns="45720" tIns="27432" bIns="27432" anchor="t">
+          <a:bodyPr wrap="square" lIns="45720" tIns="27432" rIns="45720" bIns="27432" anchor="t">
             <a:spAutoFit/>
           </a:bodyPr>
           <a:lstStyle/>
@@ -6966,6 +7007,7 @@
           <a:lstStyle/>
           <a:p>
             <a:pPr algn="ctr"/>
+            <a:endParaRPr/>
           </a:p>
         </p:txBody>
       </p:sp>
@@ -7011,6 +7053,7 @@
           <a:lstStyle/>
           <a:p>
             <a:pPr algn="ctr"/>
+            <a:endParaRPr/>
           </a:p>
         </p:txBody>
       </p:sp>
@@ -7031,7 +7074,7 @@
           <a:noFill/>
         </p:spPr>
         <p:txBody>
-          <a:bodyPr wrap="square" lIns="45720" rIns="45720" tIns="27432" bIns="27432" anchor="t">
+          <a:bodyPr wrap="square" lIns="45720" tIns="27432" rIns="45720" bIns="27432" anchor="t">
             <a:spAutoFit/>
           </a:bodyPr>
           <a:lstStyle/>
@@ -7066,7 +7109,7 @@
           <a:noFill/>
         </p:spPr>
         <p:txBody>
-          <a:bodyPr wrap="square" lIns="45720" rIns="45720" tIns="27432" bIns="27432" anchor="t">
+          <a:bodyPr wrap="square" lIns="45720" tIns="27432" rIns="45720" bIns="27432" anchor="t">
             <a:spAutoFit/>
           </a:bodyPr>
           <a:lstStyle/>
@@ -7126,6 +7169,7 @@
           <a:lstStyle/>
           <a:p>
             <a:pPr algn="ctr"/>
+            <a:endParaRPr/>
           </a:p>
         </p:txBody>
       </p:sp>
@@ -7171,6 +7215,7 @@
           <a:lstStyle/>
           <a:p>
             <a:pPr algn="ctr"/>
+            <a:endParaRPr/>
           </a:p>
         </p:txBody>
       </p:sp>
@@ -7191,7 +7236,7 @@
           <a:noFill/>
         </p:spPr>
         <p:txBody>
-          <a:bodyPr wrap="square" lIns="45720" rIns="45720" tIns="27432" bIns="27432" anchor="t">
+          <a:bodyPr wrap="square" lIns="45720" tIns="27432" rIns="45720" bIns="27432" anchor="t">
             <a:spAutoFit/>
           </a:bodyPr>
           <a:lstStyle/>
@@ -7218,7 +7263,7 @@
 </file>
 
 <file path=ppt/slides/slide13.xml><?xml version="1.0" encoding="utf-8"?>
-<p:sld xmlns:a="http://schemas.openxmlformats.org/drawingml/2006/main" xmlns:p="http://schemas.openxmlformats.org/presentationml/2006/main" xmlns:r="http://schemas.openxmlformats.org/officeDocument/2006/relationships">
+<p:sld xmlns:a="http://schemas.openxmlformats.org/drawingml/2006/main" xmlns:r="http://schemas.openxmlformats.org/officeDocument/2006/relationships" xmlns:p="http://schemas.openxmlformats.org/presentationml/2006/main">
   <p:cSld>
     <p:bg>
       <p:bgPr>
@@ -7234,7 +7279,14 @@
         <p:cNvGrpSpPr/>
         <p:nvPr/>
       </p:nvGrpSpPr>
-      <p:grpSpPr/>
+      <p:grpSpPr>
+        <a:xfrm>
+          <a:off x="0" y="0"/>
+          <a:ext cx="0" cy="0"/>
+          <a:chOff x="0" y="0"/>
+          <a:chExt cx="0" cy="0"/>
+        </a:xfrm>
+      </p:grpSpPr>
       <p:sp>
         <p:nvSpPr>
           <p:cNvPr id="2" name="TextBox 1"/>
@@ -7252,7 +7304,7 @@
           <a:noFill/>
         </p:spPr>
         <p:txBody>
-          <a:bodyPr wrap="square" lIns="45720" rIns="45720" tIns="27432" bIns="27432" anchor="t">
+          <a:bodyPr wrap="square" lIns="45720" tIns="27432" rIns="45720" bIns="27432" anchor="t">
             <a:spAutoFit/>
           </a:bodyPr>
           <a:lstStyle/>
@@ -7287,7 +7339,7 @@
           <a:noFill/>
         </p:spPr>
         <p:txBody>
-          <a:bodyPr wrap="square" lIns="45720" rIns="45720" tIns="27432" bIns="27432" anchor="t">
+          <a:bodyPr wrap="square" lIns="45720" tIns="27432" rIns="45720" bIns="27432" anchor="t">
             <a:spAutoFit/>
           </a:bodyPr>
           <a:lstStyle/>
@@ -7326,7 +7378,7 @@
           <a:noFill/>
         </p:spPr>
         <p:txBody>
-          <a:bodyPr wrap="square" lIns="45720" rIns="45720" tIns="27432" bIns="27432" anchor="t">
+          <a:bodyPr wrap="square" lIns="45720" tIns="27432" rIns="45720" bIns="27432" anchor="t">
             <a:spAutoFit/>
           </a:bodyPr>
           <a:lstStyle/>
@@ -7382,7 +7434,7 @@
           </a:fontRef>
         </p:style>
         <p:txBody>
-          <a:bodyPr rtlCol="0" anchor="ctr" lIns="146304" rIns="146304" tIns="91440" bIns="73152"/>
+          <a:bodyPr lIns="146304" tIns="91440" rIns="146304" bIns="73152" rtlCol="0" anchor="ctr"/>
           <a:lstStyle/>
           <a:p>
             <a:pPr algn="ctr"/>
@@ -7452,7 +7504,7 @@
           </a:fontRef>
         </p:style>
         <p:txBody>
-          <a:bodyPr rtlCol="0" anchor="ctr" lIns="146304" rIns="146304" tIns="91440" bIns="73152"/>
+          <a:bodyPr lIns="146304" tIns="91440" rIns="146304" bIns="73152" rtlCol="0" anchor="ctr"/>
           <a:lstStyle/>
           <a:p>
             <a:pPr algn="ctr"/>
@@ -7522,7 +7574,7 @@
           </a:fontRef>
         </p:style>
         <p:txBody>
-          <a:bodyPr rtlCol="0" anchor="ctr" wrap="square" lIns="164592" rIns="164592" tIns="109728" bIns="91440"/>
+          <a:bodyPr wrap="square" lIns="164592" tIns="109728" rIns="164592" bIns="91440" rtlCol="0" anchor="ctr"/>
           <a:lstStyle/>
           <a:p>
             <a:pPr algn="ctr"/>
@@ -7624,7 +7676,7 @@
           </a:fontRef>
         </p:style>
         <p:txBody>
-          <a:bodyPr rtlCol="0" anchor="ctr" wrap="square" lIns="164592" rIns="164592" tIns="109728" bIns="91440"/>
+          <a:bodyPr wrap="square" lIns="164592" tIns="109728" rIns="164592" bIns="91440" rtlCol="0" anchor="ctr"/>
           <a:lstStyle/>
           <a:p>
             <a:pPr algn="ctr"/>
@@ -7726,7 +7778,7 @@
           </a:fontRef>
         </p:style>
         <p:txBody>
-          <a:bodyPr rtlCol="0" anchor="ctr" wrap="square" lIns="164592" rIns="164592" tIns="109728" bIns="91440"/>
+          <a:bodyPr wrap="square" lIns="164592" tIns="109728" rIns="164592" bIns="91440" rtlCol="0" anchor="ctr"/>
           <a:lstStyle/>
           <a:p>
             <a:pPr algn="ctr"/>
@@ -7799,7 +7851,7 @@
 </file>
 
 <file path=ppt/slides/slide14.xml><?xml version="1.0" encoding="utf-8"?>
-<p:sld xmlns:a="http://schemas.openxmlformats.org/drawingml/2006/main" xmlns:p="http://schemas.openxmlformats.org/presentationml/2006/main" xmlns:r="http://schemas.openxmlformats.org/officeDocument/2006/relationships">
+<p:sld xmlns:a="http://schemas.openxmlformats.org/drawingml/2006/main" xmlns:r="http://schemas.openxmlformats.org/officeDocument/2006/relationships" xmlns:p="http://schemas.openxmlformats.org/presentationml/2006/main">
   <p:cSld>
     <p:bg>
       <p:bgPr>
@@ -7815,7 +7867,14 @@
         <p:cNvGrpSpPr/>
         <p:nvPr/>
       </p:nvGrpSpPr>
-      <p:grpSpPr/>
+      <p:grpSpPr>
+        <a:xfrm>
+          <a:off x="0" y="0"/>
+          <a:ext cx="0" cy="0"/>
+          <a:chOff x="0" y="0"/>
+          <a:chExt cx="0" cy="0"/>
+        </a:xfrm>
+      </p:grpSpPr>
       <p:sp>
         <p:nvSpPr>
           <p:cNvPr id="2" name="TextBox 1"/>
@@ -7833,7 +7892,7 @@
           <a:noFill/>
         </p:spPr>
         <p:txBody>
-          <a:bodyPr wrap="square" lIns="45720" rIns="45720" tIns="27432" bIns="27432" anchor="t">
+          <a:bodyPr wrap="square" lIns="45720" tIns="27432" rIns="45720" bIns="27432" anchor="t">
             <a:spAutoFit/>
           </a:bodyPr>
           <a:lstStyle/>
@@ -7868,7 +7927,7 @@
           <a:noFill/>
         </p:spPr>
         <p:txBody>
-          <a:bodyPr wrap="square" lIns="45720" rIns="45720" tIns="27432" bIns="27432" anchor="t">
+          <a:bodyPr wrap="square" lIns="45720" tIns="27432" rIns="45720" bIns="27432" anchor="t">
             <a:spAutoFit/>
           </a:bodyPr>
           <a:lstStyle/>
@@ -7903,7 +7962,7 @@
           <a:noFill/>
         </p:spPr>
         <p:txBody>
-          <a:bodyPr wrap="square" lIns="45720" rIns="45720" tIns="27432" bIns="27432" anchor="t">
+          <a:bodyPr wrap="square" lIns="45720" tIns="27432" rIns="45720" bIns="27432" anchor="t">
             <a:spAutoFit/>
           </a:bodyPr>
           <a:lstStyle/>
@@ -7959,7 +8018,7 @@
           </a:fontRef>
         </p:style>
         <p:txBody>
-          <a:bodyPr rtlCol="0" anchor="ctr" wrap="square" lIns="164592" rIns="164592" tIns="109728" bIns="91440"/>
+          <a:bodyPr wrap="square" lIns="164592" tIns="109728" rIns="164592" bIns="91440" rtlCol="0" anchor="ctr"/>
           <a:lstStyle/>
           <a:p>
             <a:pPr algn="ctr"/>
@@ -8077,7 +8136,7 @@
           </a:fontRef>
         </p:style>
         <p:txBody>
-          <a:bodyPr rtlCol="0" anchor="ctr" lIns="146304" rIns="146304" tIns="91440" bIns="73152"/>
+          <a:bodyPr lIns="146304" tIns="91440" rIns="146304" bIns="73152" rtlCol="0" anchor="ctr"/>
           <a:lstStyle/>
           <a:p>
             <a:pPr algn="ctr"/>
@@ -8110,7 +8169,7 @@
           <a:noFill/>
         </p:spPr>
         <p:txBody>
-          <a:bodyPr wrap="square" lIns="45720" rIns="45720" tIns="27432" bIns="27432" anchor="t">
+          <a:bodyPr wrap="square" lIns="45720" tIns="27432" rIns="45720" bIns="27432" anchor="t">
             <a:spAutoFit/>
           </a:bodyPr>
           <a:lstStyle/>
@@ -8145,7 +8204,7 @@
           <a:noFill/>
         </p:spPr>
         <p:txBody>
-          <a:bodyPr wrap="square" lIns="45720" rIns="45720" tIns="27432" bIns="27432" anchor="t">
+          <a:bodyPr wrap="square" lIns="45720" tIns="27432" rIns="45720" bIns="27432" anchor="t">
             <a:spAutoFit/>
           </a:bodyPr>
           <a:lstStyle/>
@@ -8180,7 +8239,7 @@
           <a:noFill/>
         </p:spPr>
         <p:txBody>
-          <a:bodyPr wrap="square" lIns="45720" rIns="45720" tIns="27432" bIns="27432" anchor="t">
+          <a:bodyPr wrap="square" lIns="45720" tIns="27432" rIns="45720" bIns="27432" anchor="t">
             <a:spAutoFit/>
           </a:bodyPr>
           <a:lstStyle/>
@@ -8215,7 +8274,7 @@
           <a:noFill/>
         </p:spPr>
         <p:txBody>
-          <a:bodyPr wrap="square" lIns="45720" rIns="45720" tIns="27432" bIns="27432" anchor="t">
+          <a:bodyPr wrap="square" lIns="45720" tIns="27432" rIns="45720" bIns="27432" anchor="t">
             <a:spAutoFit/>
           </a:bodyPr>
           <a:lstStyle/>
@@ -8250,7 +8309,7 @@
           <a:noFill/>
         </p:spPr>
         <p:txBody>
-          <a:bodyPr wrap="square" lIns="45720" rIns="45720" tIns="27432" bIns="27432" anchor="t">
+          <a:bodyPr wrap="square" lIns="45720" tIns="27432" rIns="45720" bIns="27432" anchor="t">
             <a:spAutoFit/>
           </a:bodyPr>
           <a:lstStyle/>
@@ -8285,7 +8344,7 @@
           <a:noFill/>
         </p:spPr>
         <p:txBody>
-          <a:bodyPr wrap="square" lIns="45720" rIns="45720" tIns="27432" bIns="27432" anchor="t">
+          <a:bodyPr wrap="square" lIns="45720" tIns="27432" rIns="45720" bIns="27432" anchor="t">
             <a:spAutoFit/>
           </a:bodyPr>
           <a:lstStyle/>
@@ -8320,7 +8379,7 @@
           <a:noFill/>
         </p:spPr>
         <p:txBody>
-          <a:bodyPr wrap="square" lIns="45720" rIns="45720" tIns="27432" bIns="27432" anchor="t">
+          <a:bodyPr wrap="square" lIns="45720" tIns="27432" rIns="45720" bIns="27432" anchor="t">
             <a:spAutoFit/>
           </a:bodyPr>
           <a:lstStyle/>
@@ -8355,7 +8414,7 @@
           <a:noFill/>
         </p:spPr>
         <p:txBody>
-          <a:bodyPr wrap="square" lIns="45720" rIns="45720" tIns="27432" bIns="27432" anchor="t">
+          <a:bodyPr wrap="square" lIns="45720" tIns="27432" rIns="45720" bIns="27432" anchor="t">
             <a:spAutoFit/>
           </a:bodyPr>
           <a:lstStyle/>
@@ -8411,7 +8470,7 @@
           </a:fontRef>
         </p:style>
         <p:txBody>
-          <a:bodyPr rtlCol="0" anchor="ctr" lIns="146304" rIns="146304" tIns="91440" bIns="73152"/>
+          <a:bodyPr lIns="146304" tIns="91440" rIns="146304" bIns="73152" rtlCol="0" anchor="ctr"/>
           <a:lstStyle/>
           <a:p>
             <a:pPr algn="ctr"/>
@@ -8444,7 +8503,7 @@
           <a:noFill/>
         </p:spPr>
         <p:txBody>
-          <a:bodyPr wrap="square" lIns="45720" rIns="45720" tIns="27432" bIns="27432" anchor="t">
+          <a:bodyPr wrap="square" lIns="45720" tIns="27432" rIns="45720" bIns="27432" anchor="t">
             <a:spAutoFit/>
           </a:bodyPr>
           <a:lstStyle/>
@@ -8504,6 +8563,7 @@
           <a:lstStyle/>
           <a:p>
             <a:pPr algn="ctr"/>
+            <a:endParaRPr/>
           </a:p>
         </p:txBody>
       </p:sp>
@@ -8549,6 +8609,7 @@
           <a:lstStyle/>
           <a:p>
             <a:pPr algn="ctr"/>
+            <a:endParaRPr/>
           </a:p>
         </p:txBody>
       </p:sp>
@@ -8569,7 +8630,7 @@
           <a:noFill/>
         </p:spPr>
         <p:txBody>
-          <a:bodyPr wrap="square" lIns="45720" rIns="45720" tIns="27432" bIns="27432" anchor="t">
+          <a:bodyPr wrap="square" lIns="45720" tIns="27432" rIns="45720" bIns="27432" anchor="t">
             <a:spAutoFit/>
           </a:bodyPr>
           <a:lstStyle/>
@@ -8604,7 +8665,7 @@
           <a:noFill/>
         </p:spPr>
         <p:txBody>
-          <a:bodyPr wrap="square" lIns="45720" rIns="45720" tIns="27432" bIns="27432" anchor="t">
+          <a:bodyPr wrap="square" lIns="45720" tIns="27432" rIns="45720" bIns="27432" anchor="t">
             <a:spAutoFit/>
           </a:bodyPr>
           <a:lstStyle/>
@@ -8664,6 +8725,7 @@
           <a:lstStyle/>
           <a:p>
             <a:pPr algn="ctr"/>
+            <a:endParaRPr/>
           </a:p>
         </p:txBody>
       </p:sp>
@@ -8709,6 +8771,7 @@
           <a:lstStyle/>
           <a:p>
             <a:pPr algn="ctr"/>
+            <a:endParaRPr/>
           </a:p>
         </p:txBody>
       </p:sp>
@@ -8729,7 +8792,7 @@
           <a:noFill/>
         </p:spPr>
         <p:txBody>
-          <a:bodyPr wrap="square" lIns="45720" rIns="45720" tIns="27432" bIns="27432" anchor="t">
+          <a:bodyPr wrap="square" lIns="45720" tIns="27432" rIns="45720" bIns="27432" anchor="t">
             <a:spAutoFit/>
           </a:bodyPr>
           <a:lstStyle/>
@@ -8764,7 +8827,7 @@
           <a:noFill/>
         </p:spPr>
         <p:txBody>
-          <a:bodyPr wrap="square" lIns="45720" rIns="45720" tIns="27432" bIns="27432" anchor="t">
+          <a:bodyPr wrap="square" lIns="45720" tIns="27432" rIns="45720" bIns="27432" anchor="t">
             <a:spAutoFit/>
           </a:bodyPr>
           <a:lstStyle/>
@@ -8824,6 +8887,7 @@
           <a:lstStyle/>
           <a:p>
             <a:pPr algn="ctr"/>
+            <a:endParaRPr/>
           </a:p>
         </p:txBody>
       </p:sp>
@@ -8869,6 +8933,7 @@
           <a:lstStyle/>
           <a:p>
             <a:pPr algn="ctr"/>
+            <a:endParaRPr/>
           </a:p>
         </p:txBody>
       </p:sp>
@@ -8889,7 +8954,7 @@
           <a:noFill/>
         </p:spPr>
         <p:txBody>
-          <a:bodyPr wrap="square" lIns="45720" rIns="45720" tIns="27432" bIns="27432" anchor="t">
+          <a:bodyPr wrap="square" lIns="45720" tIns="27432" rIns="45720" bIns="27432" anchor="t">
             <a:spAutoFit/>
           </a:bodyPr>
           <a:lstStyle/>
@@ -8924,7 +8989,7 @@
           <a:noFill/>
         </p:spPr>
         <p:txBody>
-          <a:bodyPr wrap="square" lIns="45720" rIns="45720" tIns="27432" bIns="27432" anchor="t">
+          <a:bodyPr wrap="square" lIns="45720" tIns="27432" rIns="45720" bIns="27432" anchor="t">
             <a:spAutoFit/>
           </a:bodyPr>
           <a:lstStyle/>
@@ -8984,6 +9049,7 @@
           <a:lstStyle/>
           <a:p>
             <a:pPr algn="ctr"/>
+            <a:endParaRPr/>
           </a:p>
         </p:txBody>
       </p:sp>
@@ -9029,6 +9095,7 @@
           <a:lstStyle/>
           <a:p>
             <a:pPr algn="ctr"/>
+            <a:endParaRPr/>
           </a:p>
         </p:txBody>
       </p:sp>
@@ -9049,7 +9116,7 @@
           <a:noFill/>
         </p:spPr>
         <p:txBody>
-          <a:bodyPr wrap="square" lIns="45720" rIns="45720" tIns="27432" bIns="27432" anchor="t">
+          <a:bodyPr wrap="square" lIns="45720" tIns="27432" rIns="45720" bIns="27432" anchor="t">
             <a:spAutoFit/>
           </a:bodyPr>
           <a:lstStyle/>
@@ -9105,7 +9172,7 @@
           </a:fontRef>
         </p:style>
         <p:txBody>
-          <a:bodyPr rtlCol="0" anchor="ctr" wrap="square" lIns="164592" rIns="164592" tIns="109728" bIns="91440"/>
+          <a:bodyPr wrap="square" lIns="164592" tIns="109728" rIns="164592" bIns="91440" rtlCol="0" anchor="ctr"/>
           <a:lstStyle/>
           <a:p>
             <a:pPr algn="ctr"/>
@@ -9178,7 +9245,7 @@
 </file>
 
 <file path=ppt/slides/slide15.xml><?xml version="1.0" encoding="utf-8"?>
-<p:sld xmlns:a="http://schemas.openxmlformats.org/drawingml/2006/main" xmlns:p="http://schemas.openxmlformats.org/presentationml/2006/main" xmlns:r="http://schemas.openxmlformats.org/officeDocument/2006/relationships">
+<p:sld xmlns:a="http://schemas.openxmlformats.org/drawingml/2006/main" xmlns:r="http://schemas.openxmlformats.org/officeDocument/2006/relationships" xmlns:p="http://schemas.openxmlformats.org/presentationml/2006/main">
   <p:cSld>
     <p:bg>
       <p:bgPr>
@@ -9194,7 +9261,14 @@
         <p:cNvGrpSpPr/>
         <p:nvPr/>
       </p:nvGrpSpPr>
-      <p:grpSpPr/>
+      <p:grpSpPr>
+        <a:xfrm>
+          <a:off x="0" y="0"/>
+          <a:ext cx="0" cy="0"/>
+          <a:chOff x="0" y="0"/>
+          <a:chExt cx="0" cy="0"/>
+        </a:xfrm>
+      </p:grpSpPr>
       <p:sp>
         <p:nvSpPr>
           <p:cNvPr id="2" name="TextBox 1"/>
@@ -9212,7 +9286,7 @@
           <a:noFill/>
         </p:spPr>
         <p:txBody>
-          <a:bodyPr wrap="square" lIns="45720" rIns="45720" tIns="27432" bIns="27432" anchor="t">
+          <a:bodyPr wrap="square" lIns="45720" tIns="27432" rIns="45720" bIns="27432" anchor="t">
             <a:spAutoFit/>
           </a:bodyPr>
           <a:lstStyle/>
@@ -9247,7 +9321,7 @@
           <a:noFill/>
         </p:spPr>
         <p:txBody>
-          <a:bodyPr wrap="square" lIns="45720" rIns="45720" tIns="27432" bIns="27432" anchor="t">
+          <a:bodyPr wrap="square" lIns="45720" tIns="27432" rIns="45720" bIns="27432" anchor="t">
             <a:spAutoFit/>
           </a:bodyPr>
           <a:lstStyle/>
@@ -9282,7 +9356,7 @@
           <a:noFill/>
         </p:spPr>
         <p:txBody>
-          <a:bodyPr wrap="square" lIns="45720" rIns="45720" tIns="27432" bIns="27432" anchor="t">
+          <a:bodyPr wrap="square" lIns="45720" tIns="27432" rIns="45720" bIns="27432" anchor="t">
             <a:spAutoFit/>
           </a:bodyPr>
           <a:lstStyle/>
@@ -9338,7 +9412,7 @@
           </a:fontRef>
         </p:style>
         <p:txBody>
-          <a:bodyPr rtlCol="0" anchor="ctr" wrap="square" lIns="164592" rIns="164592" tIns="109728" bIns="91440"/>
+          <a:bodyPr wrap="square" lIns="164592" tIns="109728" rIns="164592" bIns="91440" rtlCol="0" anchor="ctr"/>
           <a:lstStyle/>
           <a:p>
             <a:pPr algn="ctr"/>
@@ -9440,7 +9514,7 @@
           </a:fontRef>
         </p:style>
         <p:txBody>
-          <a:bodyPr rtlCol="0" anchor="ctr" wrap="square" lIns="164592" rIns="164592" tIns="109728" bIns="91440"/>
+          <a:bodyPr wrap="square" lIns="164592" tIns="109728" rIns="164592" bIns="91440" rtlCol="0" anchor="ctr"/>
           <a:lstStyle/>
           <a:p>
             <a:pPr algn="ctr"/>
@@ -9542,7 +9616,7 @@
           </a:fontRef>
         </p:style>
         <p:txBody>
-          <a:bodyPr rtlCol="0" anchor="ctr" wrap="square" lIns="164592" rIns="164592" tIns="109728" bIns="91440"/>
+          <a:bodyPr wrap="square" lIns="164592" tIns="109728" rIns="164592" bIns="91440" rtlCol="0" anchor="ctr"/>
           <a:lstStyle/>
           <a:p>
             <a:pPr algn="ctr"/>
@@ -9628,7 +9702,7 @@
           </a:fontRef>
         </p:style>
         <p:txBody>
-          <a:bodyPr rtlCol="0" anchor="ctr" wrap="square" lIns="164592" rIns="164592" tIns="109728" bIns="91440"/>
+          <a:bodyPr wrap="square" lIns="164592" tIns="109728" rIns="164592" bIns="91440" rtlCol="0" anchor="ctr"/>
           <a:lstStyle/>
           <a:p>
             <a:pPr algn="ctr"/>
@@ -9714,7 +9788,7 @@
           </a:fontRef>
         </p:style>
         <p:txBody>
-          <a:bodyPr rtlCol="0" anchor="ctr" wrap="square" lIns="164592" rIns="164592" tIns="109728" bIns="91440"/>
+          <a:bodyPr wrap="square" lIns="164592" tIns="109728" rIns="164592" bIns="91440" rtlCol="0" anchor="ctr"/>
           <a:lstStyle/>
           <a:p>
             <a:pPr algn="ctr"/>
@@ -9771,7 +9845,7 @@
 </file>
 
 <file path=ppt/slides/slide2.xml><?xml version="1.0" encoding="utf-8"?>
-<p:sld xmlns:a="http://schemas.openxmlformats.org/drawingml/2006/main" xmlns:p="http://schemas.openxmlformats.org/presentationml/2006/main" xmlns:r="http://schemas.openxmlformats.org/officeDocument/2006/relationships">
+<p:sld xmlns:a="http://schemas.openxmlformats.org/drawingml/2006/main" xmlns:r="http://schemas.openxmlformats.org/officeDocument/2006/relationships" xmlns:p="http://schemas.openxmlformats.org/presentationml/2006/main">
   <p:cSld>
     <p:bg>
       <p:bgPr>
@@ -9787,7 +9861,14 @@
         <p:cNvGrpSpPr/>
         <p:nvPr/>
       </p:nvGrpSpPr>
-      <p:grpSpPr/>
+      <p:grpSpPr>
+        <a:xfrm>
+          <a:off x="0" y="0"/>
+          <a:ext cx="0" cy="0"/>
+          <a:chOff x="0" y="0"/>
+          <a:chExt cx="0" cy="0"/>
+        </a:xfrm>
+      </p:grpSpPr>
       <p:sp>
         <p:nvSpPr>
           <p:cNvPr id="2" name="TextBox 1"/>
@@ -9805,7 +9886,7 @@
           <a:noFill/>
         </p:spPr>
         <p:txBody>
-          <a:bodyPr wrap="square" lIns="45720" rIns="45720" tIns="27432" bIns="27432" anchor="t">
+          <a:bodyPr wrap="square" lIns="45720" tIns="27432" rIns="45720" bIns="27432" anchor="t">
             <a:spAutoFit/>
           </a:bodyPr>
           <a:lstStyle/>
@@ -9840,7 +9921,7 @@
           <a:noFill/>
         </p:spPr>
         <p:txBody>
-          <a:bodyPr wrap="square" lIns="45720" rIns="45720" tIns="27432" bIns="27432" anchor="t">
+          <a:bodyPr wrap="square" lIns="45720" tIns="27432" rIns="45720" bIns="27432" anchor="t">
             <a:spAutoFit/>
           </a:bodyPr>
           <a:lstStyle/>
@@ -9879,7 +9960,7 @@
           <a:noFill/>
         </p:spPr>
         <p:txBody>
-          <a:bodyPr wrap="square" lIns="45720" rIns="45720" tIns="27432" bIns="27432" anchor="t">
+          <a:bodyPr wrap="square" lIns="45720" tIns="27432" rIns="45720" bIns="27432" anchor="t">
             <a:spAutoFit/>
           </a:bodyPr>
           <a:lstStyle/>
@@ -9935,7 +10016,7 @@
           </a:fontRef>
         </p:style>
         <p:txBody>
-          <a:bodyPr rtlCol="0" anchor="ctr" lIns="146304" rIns="146304" tIns="91440" bIns="73152"/>
+          <a:bodyPr lIns="146304" tIns="91440" rIns="146304" bIns="73152" rtlCol="0" anchor="ctr"/>
           <a:lstStyle/>
           <a:p>
             <a:pPr algn="ctr"/>
@@ -10005,7 +10086,7 @@
           </a:fontRef>
         </p:style>
         <p:txBody>
-          <a:bodyPr rtlCol="0" anchor="ctr" lIns="146304" rIns="146304" tIns="91440" bIns="73152"/>
+          <a:bodyPr lIns="146304" tIns="91440" rIns="146304" bIns="73152" rtlCol="0" anchor="ctr"/>
           <a:lstStyle/>
           <a:p>
             <a:pPr algn="ctr"/>
@@ -10075,7 +10156,7 @@
           </a:fontRef>
         </p:style>
         <p:txBody>
-          <a:bodyPr rtlCol="0" anchor="ctr" wrap="square" lIns="164592" rIns="164592" tIns="109728" bIns="91440"/>
+          <a:bodyPr wrap="square" lIns="164592" tIns="109728" rIns="164592" bIns="91440" rtlCol="0" anchor="ctr"/>
           <a:lstStyle/>
           <a:p>
             <a:pPr algn="ctr"/>
@@ -10177,7 +10258,7 @@
           </a:fontRef>
         </p:style>
         <p:txBody>
-          <a:bodyPr rtlCol="0" anchor="ctr" wrap="square" lIns="164592" rIns="164592" tIns="109728" bIns="91440"/>
+          <a:bodyPr wrap="square" lIns="164592" tIns="109728" rIns="164592" bIns="91440" rtlCol="0" anchor="ctr"/>
           <a:lstStyle/>
           <a:p>
             <a:pPr algn="ctr"/>
@@ -10279,7 +10360,7 @@
           </a:fontRef>
         </p:style>
         <p:txBody>
-          <a:bodyPr rtlCol="0" anchor="ctr" wrap="square" lIns="164592" rIns="164592" tIns="109728" bIns="91440"/>
+          <a:bodyPr wrap="square" lIns="164592" tIns="109728" rIns="164592" bIns="91440" rtlCol="0" anchor="ctr"/>
           <a:lstStyle/>
           <a:p>
             <a:pPr algn="ctr"/>
@@ -10352,7 +10433,7 @@
 </file>
 
 <file path=ppt/slides/slide3.xml><?xml version="1.0" encoding="utf-8"?>
-<p:sld xmlns:a="http://schemas.openxmlformats.org/drawingml/2006/main" xmlns:p="http://schemas.openxmlformats.org/presentationml/2006/main" xmlns:r="http://schemas.openxmlformats.org/officeDocument/2006/relationships">
+<p:sld xmlns:a="http://schemas.openxmlformats.org/drawingml/2006/main" xmlns:r="http://schemas.openxmlformats.org/officeDocument/2006/relationships" xmlns:p="http://schemas.openxmlformats.org/presentationml/2006/main">
   <p:cSld>
     <p:bg>
       <p:bgPr>
@@ -10368,7 +10449,14 @@
         <p:cNvGrpSpPr/>
         <p:nvPr/>
       </p:nvGrpSpPr>
-      <p:grpSpPr/>
+      <p:grpSpPr>
+        <a:xfrm>
+          <a:off x="0" y="0"/>
+          <a:ext cx="0" cy="0"/>
+          <a:chOff x="0" y="0"/>
+          <a:chExt cx="0" cy="0"/>
+        </a:xfrm>
+      </p:grpSpPr>
       <p:sp>
         <p:nvSpPr>
           <p:cNvPr id="2" name="TextBox 1"/>
@@ -10386,7 +10474,7 @@
           <a:noFill/>
         </p:spPr>
         <p:txBody>
-          <a:bodyPr wrap="square" lIns="45720" rIns="45720" tIns="27432" bIns="27432" anchor="t">
+          <a:bodyPr wrap="square" lIns="45720" tIns="27432" rIns="45720" bIns="27432" anchor="t">
             <a:spAutoFit/>
           </a:bodyPr>
           <a:lstStyle/>
@@ -10421,7 +10509,7 @@
           <a:noFill/>
         </p:spPr>
         <p:txBody>
-          <a:bodyPr wrap="square" lIns="45720" rIns="45720" tIns="27432" bIns="27432" anchor="t">
+          <a:bodyPr wrap="square" lIns="45720" tIns="27432" rIns="45720" bIns="27432" anchor="t">
             <a:spAutoFit/>
           </a:bodyPr>
           <a:lstStyle/>
@@ -10456,7 +10544,7 @@
           <a:noFill/>
         </p:spPr>
         <p:txBody>
-          <a:bodyPr wrap="square" lIns="45720" rIns="45720" tIns="27432" bIns="27432" anchor="t">
+          <a:bodyPr wrap="square" lIns="45720" tIns="27432" rIns="45720" bIns="27432" anchor="t">
             <a:spAutoFit/>
           </a:bodyPr>
           <a:lstStyle/>
@@ -10512,7 +10600,7 @@
           </a:fontRef>
         </p:style>
         <p:txBody>
-          <a:bodyPr rtlCol="0" anchor="ctr" wrap="square" lIns="164592" rIns="164592" tIns="109728" bIns="91440"/>
+          <a:bodyPr wrap="square" lIns="164592" tIns="109728" rIns="164592" bIns="91440" rtlCol="0" anchor="ctr"/>
           <a:lstStyle/>
           <a:p>
             <a:pPr algn="ctr"/>
@@ -10630,7 +10718,7 @@
           </a:fontRef>
         </p:style>
         <p:txBody>
-          <a:bodyPr rtlCol="0" anchor="ctr" lIns="146304" rIns="146304" tIns="91440" bIns="73152"/>
+          <a:bodyPr lIns="146304" tIns="91440" rIns="146304" bIns="73152" rtlCol="0" anchor="ctr"/>
           <a:lstStyle/>
           <a:p>
             <a:pPr algn="ctr"/>
@@ -10663,7 +10751,7 @@
           <a:noFill/>
         </p:spPr>
         <p:txBody>
-          <a:bodyPr wrap="square" lIns="45720" rIns="45720" tIns="27432" bIns="27432" anchor="t">
+          <a:bodyPr wrap="square" lIns="45720" tIns="27432" rIns="45720" bIns="27432" anchor="t">
             <a:spAutoFit/>
           </a:bodyPr>
           <a:lstStyle/>
@@ -10698,7 +10786,7 @@
           <a:noFill/>
         </p:spPr>
         <p:txBody>
-          <a:bodyPr wrap="square" lIns="45720" rIns="45720" tIns="27432" bIns="27432" anchor="t">
+          <a:bodyPr wrap="square" lIns="45720" tIns="27432" rIns="45720" bIns="27432" anchor="t">
             <a:spAutoFit/>
           </a:bodyPr>
           <a:lstStyle/>
@@ -10733,7 +10821,7 @@
           <a:noFill/>
         </p:spPr>
         <p:txBody>
-          <a:bodyPr wrap="square" lIns="45720" rIns="45720" tIns="27432" bIns="27432" anchor="t">
+          <a:bodyPr wrap="square" lIns="45720" tIns="27432" rIns="45720" bIns="27432" anchor="t">
             <a:spAutoFit/>
           </a:bodyPr>
           <a:lstStyle/>
@@ -10768,7 +10856,7 @@
           <a:noFill/>
         </p:spPr>
         <p:txBody>
-          <a:bodyPr wrap="square" lIns="45720" rIns="45720" tIns="27432" bIns="27432" anchor="t">
+          <a:bodyPr wrap="square" lIns="45720" tIns="27432" rIns="45720" bIns="27432" anchor="t">
             <a:spAutoFit/>
           </a:bodyPr>
           <a:lstStyle/>
@@ -10803,7 +10891,7 @@
           <a:noFill/>
         </p:spPr>
         <p:txBody>
-          <a:bodyPr wrap="square" lIns="45720" rIns="45720" tIns="27432" bIns="27432" anchor="t">
+          <a:bodyPr wrap="square" lIns="45720" tIns="27432" rIns="45720" bIns="27432" anchor="t">
             <a:spAutoFit/>
           </a:bodyPr>
           <a:lstStyle/>
@@ -10838,7 +10926,7 @@
           <a:noFill/>
         </p:spPr>
         <p:txBody>
-          <a:bodyPr wrap="square" lIns="45720" rIns="45720" tIns="27432" bIns="27432" anchor="t">
+          <a:bodyPr wrap="square" lIns="45720" tIns="27432" rIns="45720" bIns="27432" anchor="t">
             <a:spAutoFit/>
           </a:bodyPr>
           <a:lstStyle/>
@@ -10873,7 +10961,7 @@
           <a:noFill/>
         </p:spPr>
         <p:txBody>
-          <a:bodyPr wrap="square" lIns="45720" rIns="45720" tIns="27432" bIns="27432" anchor="t">
+          <a:bodyPr wrap="square" lIns="45720" tIns="27432" rIns="45720" bIns="27432" anchor="t">
             <a:spAutoFit/>
           </a:bodyPr>
           <a:lstStyle/>
@@ -10908,7 +10996,7 @@
           <a:noFill/>
         </p:spPr>
         <p:txBody>
-          <a:bodyPr wrap="square" lIns="45720" rIns="45720" tIns="27432" bIns="27432" anchor="t">
+          <a:bodyPr wrap="square" lIns="45720" tIns="27432" rIns="45720" bIns="27432" anchor="t">
             <a:spAutoFit/>
           </a:bodyPr>
           <a:lstStyle/>
@@ -10964,7 +11052,7 @@
           </a:fontRef>
         </p:style>
         <p:txBody>
-          <a:bodyPr rtlCol="0" anchor="ctr" lIns="146304" rIns="146304" tIns="91440" bIns="73152"/>
+          <a:bodyPr lIns="146304" tIns="91440" rIns="146304" bIns="73152" rtlCol="0" anchor="ctr"/>
           <a:lstStyle/>
           <a:p>
             <a:pPr algn="ctr"/>
@@ -10997,7 +11085,7 @@
           <a:noFill/>
         </p:spPr>
         <p:txBody>
-          <a:bodyPr wrap="square" lIns="45720" rIns="45720" tIns="27432" bIns="27432" anchor="t">
+          <a:bodyPr wrap="square" lIns="45720" tIns="27432" rIns="45720" bIns="27432" anchor="t">
             <a:spAutoFit/>
           </a:bodyPr>
           <a:lstStyle/>
@@ -11057,6 +11145,7 @@
           <a:lstStyle/>
           <a:p>
             <a:pPr algn="ctr"/>
+            <a:endParaRPr/>
           </a:p>
         </p:txBody>
       </p:sp>
@@ -11102,6 +11191,7 @@
           <a:lstStyle/>
           <a:p>
             <a:pPr algn="ctr"/>
+            <a:endParaRPr/>
           </a:p>
         </p:txBody>
       </p:sp>
@@ -11122,7 +11212,7 @@
           <a:noFill/>
         </p:spPr>
         <p:txBody>
-          <a:bodyPr wrap="square" lIns="45720" rIns="45720" tIns="27432" bIns="27432" anchor="t">
+          <a:bodyPr wrap="square" lIns="45720" tIns="27432" rIns="45720" bIns="27432" anchor="t">
             <a:spAutoFit/>
           </a:bodyPr>
           <a:lstStyle/>
@@ -11157,7 +11247,7 @@
           <a:noFill/>
         </p:spPr>
         <p:txBody>
-          <a:bodyPr wrap="square" lIns="45720" rIns="45720" tIns="27432" bIns="27432" anchor="t">
+          <a:bodyPr wrap="square" lIns="45720" tIns="27432" rIns="45720" bIns="27432" anchor="t">
             <a:spAutoFit/>
           </a:bodyPr>
           <a:lstStyle/>
@@ -11217,6 +11307,7 @@
           <a:lstStyle/>
           <a:p>
             <a:pPr algn="ctr"/>
+            <a:endParaRPr/>
           </a:p>
         </p:txBody>
       </p:sp>
@@ -11262,6 +11353,7 @@
           <a:lstStyle/>
           <a:p>
             <a:pPr algn="ctr"/>
+            <a:endParaRPr/>
           </a:p>
         </p:txBody>
       </p:sp>
@@ -11282,7 +11374,7 @@
           <a:noFill/>
         </p:spPr>
         <p:txBody>
-          <a:bodyPr wrap="square" lIns="45720" rIns="45720" tIns="27432" bIns="27432" anchor="t">
+          <a:bodyPr wrap="square" lIns="45720" tIns="27432" rIns="45720" bIns="27432" anchor="t">
             <a:spAutoFit/>
           </a:bodyPr>
           <a:lstStyle/>
@@ -11317,7 +11409,7 @@
           <a:noFill/>
         </p:spPr>
         <p:txBody>
-          <a:bodyPr wrap="square" lIns="45720" rIns="45720" tIns="27432" bIns="27432" anchor="t">
+          <a:bodyPr wrap="square" lIns="45720" tIns="27432" rIns="45720" bIns="27432" anchor="t">
             <a:spAutoFit/>
           </a:bodyPr>
           <a:lstStyle/>
@@ -11377,6 +11469,7 @@
           <a:lstStyle/>
           <a:p>
             <a:pPr algn="ctr"/>
+            <a:endParaRPr/>
           </a:p>
         </p:txBody>
       </p:sp>
@@ -11422,6 +11515,7 @@
           <a:lstStyle/>
           <a:p>
             <a:pPr algn="ctr"/>
+            <a:endParaRPr/>
           </a:p>
         </p:txBody>
       </p:sp>
@@ -11442,7 +11536,7 @@
           <a:noFill/>
         </p:spPr>
         <p:txBody>
-          <a:bodyPr wrap="square" lIns="45720" rIns="45720" tIns="27432" bIns="27432" anchor="t">
+          <a:bodyPr wrap="square" lIns="45720" tIns="27432" rIns="45720" bIns="27432" anchor="t">
             <a:spAutoFit/>
           </a:bodyPr>
           <a:lstStyle/>
@@ -11498,7 +11592,7 @@
           </a:fontRef>
         </p:style>
         <p:txBody>
-          <a:bodyPr rtlCol="0" anchor="ctr" lIns="146304" rIns="146304" tIns="91440" bIns="73152"/>
+          <a:bodyPr lIns="146304" tIns="91440" rIns="146304" bIns="73152" rtlCol="0" anchor="ctr"/>
           <a:lstStyle/>
           <a:p>
             <a:pPr algn="ctr"/>
@@ -11531,7 +11625,7 @@
           <a:noFill/>
         </p:spPr>
         <p:txBody>
-          <a:bodyPr wrap="square" lIns="45720" rIns="45720" tIns="27432" bIns="27432" anchor="t">
+          <a:bodyPr wrap="square" lIns="45720" tIns="27432" rIns="45720" bIns="27432" anchor="t">
             <a:spAutoFit/>
           </a:bodyPr>
           <a:lstStyle/>
@@ -11591,6 +11685,7 @@
           <a:lstStyle/>
           <a:p>
             <a:pPr algn="ctr"/>
+            <a:endParaRPr/>
           </a:p>
         </p:txBody>
       </p:sp>
@@ -11636,6 +11731,7 @@
           <a:lstStyle/>
           <a:p>
             <a:pPr algn="ctr"/>
+            <a:endParaRPr/>
           </a:p>
         </p:txBody>
       </p:sp>
@@ -11656,7 +11752,7 @@
           <a:noFill/>
         </p:spPr>
         <p:txBody>
-          <a:bodyPr wrap="square" lIns="45720" rIns="45720" tIns="27432" bIns="27432" anchor="t">
+          <a:bodyPr wrap="square" lIns="45720" tIns="27432" rIns="45720" bIns="27432" anchor="t">
             <a:spAutoFit/>
           </a:bodyPr>
           <a:lstStyle/>
@@ -11691,7 +11787,7 @@
           <a:noFill/>
         </p:spPr>
         <p:txBody>
-          <a:bodyPr wrap="square" lIns="45720" rIns="45720" tIns="27432" bIns="27432" anchor="t">
+          <a:bodyPr wrap="square" lIns="45720" tIns="27432" rIns="45720" bIns="27432" anchor="t">
             <a:spAutoFit/>
           </a:bodyPr>
           <a:lstStyle/>
@@ -11751,6 +11847,7 @@
           <a:lstStyle/>
           <a:p>
             <a:pPr algn="ctr"/>
+            <a:endParaRPr/>
           </a:p>
         </p:txBody>
       </p:sp>
@@ -11796,6 +11893,7 @@
           <a:lstStyle/>
           <a:p>
             <a:pPr algn="ctr"/>
+            <a:endParaRPr/>
           </a:p>
         </p:txBody>
       </p:sp>
@@ -11816,7 +11914,7 @@
           <a:noFill/>
         </p:spPr>
         <p:txBody>
-          <a:bodyPr wrap="square" lIns="45720" rIns="45720" tIns="27432" bIns="27432" anchor="t">
+          <a:bodyPr wrap="square" lIns="45720" tIns="27432" rIns="45720" bIns="27432" anchor="t">
             <a:spAutoFit/>
           </a:bodyPr>
           <a:lstStyle/>
@@ -11851,7 +11949,7 @@
           <a:noFill/>
         </p:spPr>
         <p:txBody>
-          <a:bodyPr wrap="square" lIns="45720" rIns="45720" tIns="27432" bIns="27432" anchor="t">
+          <a:bodyPr wrap="square" lIns="45720" tIns="27432" rIns="45720" bIns="27432" anchor="t">
             <a:spAutoFit/>
           </a:bodyPr>
           <a:lstStyle/>
@@ -11911,6 +12009,7 @@
           <a:lstStyle/>
           <a:p>
             <a:pPr algn="ctr"/>
+            <a:endParaRPr/>
           </a:p>
         </p:txBody>
       </p:sp>
@@ -11956,6 +12055,7 @@
           <a:lstStyle/>
           <a:p>
             <a:pPr algn="ctr"/>
+            <a:endParaRPr/>
           </a:p>
         </p:txBody>
       </p:sp>
@@ -11976,7 +12076,7 @@
           <a:noFill/>
         </p:spPr>
         <p:txBody>
-          <a:bodyPr wrap="square" lIns="45720" rIns="45720" tIns="27432" bIns="27432" anchor="t">
+          <a:bodyPr wrap="square" lIns="45720" tIns="27432" rIns="45720" bIns="27432" anchor="t">
             <a:spAutoFit/>
           </a:bodyPr>
           <a:lstStyle/>
@@ -12011,7 +12111,7 @@
           <a:noFill/>
         </p:spPr>
         <p:txBody>
-          <a:bodyPr wrap="square" lIns="45720" rIns="45720" tIns="27432" bIns="27432" anchor="t">
+          <a:bodyPr wrap="square" lIns="45720" tIns="27432" rIns="45720" bIns="27432" anchor="t">
             <a:spAutoFit/>
           </a:bodyPr>
           <a:lstStyle/>
@@ -12071,6 +12171,7 @@
           <a:lstStyle/>
           <a:p>
             <a:pPr algn="ctr"/>
+            <a:endParaRPr/>
           </a:p>
         </p:txBody>
       </p:sp>
@@ -12116,6 +12217,7 @@
           <a:lstStyle/>
           <a:p>
             <a:pPr algn="ctr"/>
+            <a:endParaRPr/>
           </a:p>
         </p:txBody>
       </p:sp>
@@ -12136,7 +12238,7 @@
           <a:noFill/>
         </p:spPr>
         <p:txBody>
-          <a:bodyPr wrap="square" lIns="45720" rIns="45720" tIns="27432" bIns="27432" anchor="t">
+          <a:bodyPr wrap="square" lIns="45720" tIns="27432" rIns="45720" bIns="27432" anchor="t">
             <a:spAutoFit/>
           </a:bodyPr>
           <a:lstStyle/>
@@ -12163,7 +12265,7 @@
 </file>
 
 <file path=ppt/slides/slide4.xml><?xml version="1.0" encoding="utf-8"?>
-<p:sld xmlns:a="http://schemas.openxmlformats.org/drawingml/2006/main" xmlns:p="http://schemas.openxmlformats.org/presentationml/2006/main" xmlns:r="http://schemas.openxmlformats.org/officeDocument/2006/relationships">
+<p:sld xmlns:a="http://schemas.openxmlformats.org/drawingml/2006/main" xmlns:r="http://schemas.openxmlformats.org/officeDocument/2006/relationships" xmlns:p="http://schemas.openxmlformats.org/presentationml/2006/main">
   <p:cSld>
     <p:bg>
       <p:bgPr>
@@ -12179,7 +12281,14 @@
         <p:cNvGrpSpPr/>
         <p:nvPr/>
       </p:nvGrpSpPr>
-      <p:grpSpPr/>
+      <p:grpSpPr>
+        <a:xfrm>
+          <a:off x="0" y="0"/>
+          <a:ext cx="0" cy="0"/>
+          <a:chOff x="0" y="0"/>
+          <a:chExt cx="0" cy="0"/>
+        </a:xfrm>
+      </p:grpSpPr>
       <p:sp>
         <p:nvSpPr>
           <p:cNvPr id="2" name="TextBox 1"/>
@@ -12197,7 +12306,7 @@
           <a:noFill/>
         </p:spPr>
         <p:txBody>
-          <a:bodyPr wrap="square" lIns="45720" rIns="45720" tIns="27432" bIns="27432" anchor="t">
+          <a:bodyPr wrap="square" lIns="45720" tIns="27432" rIns="45720" bIns="27432" anchor="t">
             <a:spAutoFit/>
           </a:bodyPr>
           <a:lstStyle/>
@@ -12232,7 +12341,7 @@
           <a:noFill/>
         </p:spPr>
         <p:txBody>
-          <a:bodyPr wrap="square" lIns="45720" rIns="45720" tIns="27432" bIns="27432" anchor="t">
+          <a:bodyPr wrap="square" lIns="45720" tIns="27432" rIns="45720" bIns="27432" anchor="t">
             <a:spAutoFit/>
           </a:bodyPr>
           <a:lstStyle/>
@@ -12271,7 +12380,7 @@
           <a:noFill/>
         </p:spPr>
         <p:txBody>
-          <a:bodyPr wrap="square" lIns="45720" rIns="45720" tIns="27432" bIns="27432" anchor="t">
+          <a:bodyPr wrap="square" lIns="45720" tIns="27432" rIns="45720" bIns="27432" anchor="t">
             <a:spAutoFit/>
           </a:bodyPr>
           <a:lstStyle/>
@@ -12327,7 +12436,7 @@
           </a:fontRef>
         </p:style>
         <p:txBody>
-          <a:bodyPr rtlCol="0" anchor="ctr" lIns="146304" rIns="146304" tIns="91440" bIns="73152"/>
+          <a:bodyPr lIns="146304" tIns="91440" rIns="146304" bIns="73152" rtlCol="0" anchor="ctr"/>
           <a:lstStyle/>
           <a:p>
             <a:pPr algn="ctr"/>
@@ -12397,7 +12506,7 @@
           </a:fontRef>
         </p:style>
         <p:txBody>
-          <a:bodyPr rtlCol="0" anchor="ctr" lIns="146304" rIns="146304" tIns="91440" bIns="73152"/>
+          <a:bodyPr lIns="146304" tIns="91440" rIns="146304" bIns="73152" rtlCol="0" anchor="ctr"/>
           <a:lstStyle/>
           <a:p>
             <a:pPr algn="ctr"/>
@@ -12467,7 +12576,7 @@
           </a:fontRef>
         </p:style>
         <p:txBody>
-          <a:bodyPr rtlCol="0" anchor="ctr" wrap="square" lIns="164592" rIns="164592" tIns="109728" bIns="91440"/>
+          <a:bodyPr wrap="square" lIns="164592" tIns="109728" rIns="164592" bIns="91440" rtlCol="0" anchor="ctr"/>
           <a:lstStyle/>
           <a:p>
             <a:pPr algn="ctr"/>
@@ -12569,7 +12678,7 @@
           </a:fontRef>
         </p:style>
         <p:txBody>
-          <a:bodyPr rtlCol="0" anchor="ctr" wrap="square" lIns="164592" rIns="164592" tIns="109728" bIns="91440"/>
+          <a:bodyPr wrap="square" lIns="164592" tIns="109728" rIns="164592" bIns="91440" rtlCol="0" anchor="ctr"/>
           <a:lstStyle/>
           <a:p>
             <a:pPr algn="ctr"/>
@@ -12671,7 +12780,7 @@
           </a:fontRef>
         </p:style>
         <p:txBody>
-          <a:bodyPr rtlCol="0" anchor="ctr" wrap="square" lIns="164592" rIns="164592" tIns="109728" bIns="91440"/>
+          <a:bodyPr wrap="square" lIns="164592" tIns="109728" rIns="164592" bIns="91440" rtlCol="0" anchor="ctr"/>
           <a:lstStyle/>
           <a:p>
             <a:pPr algn="ctr"/>
@@ -12744,7 +12853,7 @@
 </file>
 
 <file path=ppt/slides/slide5.xml><?xml version="1.0" encoding="utf-8"?>
-<p:sld xmlns:a="http://schemas.openxmlformats.org/drawingml/2006/main" xmlns:p="http://schemas.openxmlformats.org/presentationml/2006/main" xmlns:r="http://schemas.openxmlformats.org/officeDocument/2006/relationships">
+<p:sld xmlns:a="http://schemas.openxmlformats.org/drawingml/2006/main" xmlns:r="http://schemas.openxmlformats.org/officeDocument/2006/relationships" xmlns:p="http://schemas.openxmlformats.org/presentationml/2006/main">
   <p:cSld>
     <p:bg>
       <p:bgPr>
@@ -12760,7 +12869,14 @@
         <p:cNvGrpSpPr/>
         <p:nvPr/>
       </p:nvGrpSpPr>
-      <p:grpSpPr/>
+      <p:grpSpPr>
+        <a:xfrm>
+          <a:off x="0" y="0"/>
+          <a:ext cx="0" cy="0"/>
+          <a:chOff x="0" y="0"/>
+          <a:chExt cx="0" cy="0"/>
+        </a:xfrm>
+      </p:grpSpPr>
       <p:sp>
         <p:nvSpPr>
           <p:cNvPr id="2" name="TextBox 1"/>
@@ -12778,7 +12894,7 @@
           <a:noFill/>
         </p:spPr>
         <p:txBody>
-          <a:bodyPr wrap="square" lIns="45720" rIns="45720" tIns="27432" bIns="27432" anchor="t">
+          <a:bodyPr wrap="square" lIns="45720" tIns="27432" rIns="45720" bIns="27432" anchor="t">
             <a:spAutoFit/>
           </a:bodyPr>
           <a:lstStyle/>
@@ -12813,7 +12929,7 @@
           <a:noFill/>
         </p:spPr>
         <p:txBody>
-          <a:bodyPr wrap="square" lIns="45720" rIns="45720" tIns="27432" bIns="27432" anchor="t">
+          <a:bodyPr wrap="square" lIns="45720" tIns="27432" rIns="45720" bIns="27432" anchor="t">
             <a:spAutoFit/>
           </a:bodyPr>
           <a:lstStyle/>
@@ -12848,7 +12964,7 @@
           <a:noFill/>
         </p:spPr>
         <p:txBody>
-          <a:bodyPr wrap="square" lIns="45720" rIns="45720" tIns="27432" bIns="27432" anchor="t">
+          <a:bodyPr wrap="square" lIns="45720" tIns="27432" rIns="45720" bIns="27432" anchor="t">
             <a:spAutoFit/>
           </a:bodyPr>
           <a:lstStyle/>
@@ -12904,7 +13020,7 @@
           </a:fontRef>
         </p:style>
         <p:txBody>
-          <a:bodyPr rtlCol="0" anchor="ctr" wrap="square" lIns="164592" rIns="164592" tIns="109728" bIns="91440"/>
+          <a:bodyPr wrap="square" lIns="164592" tIns="109728" rIns="164592" bIns="91440" rtlCol="0" anchor="ctr"/>
           <a:lstStyle/>
           <a:p>
             <a:pPr algn="ctr"/>
@@ -13022,7 +13138,7 @@
           </a:fontRef>
         </p:style>
         <p:txBody>
-          <a:bodyPr rtlCol="0" anchor="ctr" lIns="146304" rIns="146304" tIns="91440" bIns="73152"/>
+          <a:bodyPr lIns="146304" tIns="91440" rIns="146304" bIns="73152" rtlCol="0" anchor="ctr"/>
           <a:lstStyle/>
           <a:p>
             <a:pPr algn="ctr"/>
@@ -13055,7 +13171,7 @@
           <a:noFill/>
         </p:spPr>
         <p:txBody>
-          <a:bodyPr wrap="square" lIns="45720" rIns="45720" tIns="27432" bIns="27432" anchor="t">
+          <a:bodyPr wrap="square" lIns="45720" tIns="27432" rIns="45720" bIns="27432" anchor="t">
             <a:spAutoFit/>
           </a:bodyPr>
           <a:lstStyle/>
@@ -13090,7 +13206,7 @@
           <a:noFill/>
         </p:spPr>
         <p:txBody>
-          <a:bodyPr wrap="square" lIns="45720" rIns="45720" tIns="27432" bIns="27432" anchor="t">
+          <a:bodyPr wrap="square" lIns="45720" tIns="27432" rIns="45720" bIns="27432" anchor="t">
             <a:spAutoFit/>
           </a:bodyPr>
           <a:lstStyle/>
@@ -13125,7 +13241,7 @@
           <a:noFill/>
         </p:spPr>
         <p:txBody>
-          <a:bodyPr wrap="square" lIns="45720" rIns="45720" tIns="27432" bIns="27432" anchor="t">
+          <a:bodyPr wrap="square" lIns="45720" tIns="27432" rIns="45720" bIns="27432" anchor="t">
             <a:spAutoFit/>
           </a:bodyPr>
           <a:lstStyle/>
@@ -13160,7 +13276,7 @@
           <a:noFill/>
         </p:spPr>
         <p:txBody>
-          <a:bodyPr wrap="square" lIns="45720" rIns="45720" tIns="27432" bIns="27432" anchor="t">
+          <a:bodyPr wrap="square" lIns="45720" tIns="27432" rIns="45720" bIns="27432" anchor="t">
             <a:spAutoFit/>
           </a:bodyPr>
           <a:lstStyle/>
@@ -13195,7 +13311,7 @@
           <a:noFill/>
         </p:spPr>
         <p:txBody>
-          <a:bodyPr wrap="square" lIns="45720" rIns="45720" tIns="27432" bIns="27432" anchor="t">
+          <a:bodyPr wrap="square" lIns="45720" tIns="27432" rIns="45720" bIns="27432" anchor="t">
             <a:spAutoFit/>
           </a:bodyPr>
           <a:lstStyle/>
@@ -13230,7 +13346,7 @@
           <a:noFill/>
         </p:spPr>
         <p:txBody>
-          <a:bodyPr wrap="square" lIns="45720" rIns="45720" tIns="27432" bIns="27432" anchor="t">
+          <a:bodyPr wrap="square" lIns="45720" tIns="27432" rIns="45720" bIns="27432" anchor="t">
             <a:spAutoFit/>
           </a:bodyPr>
           <a:lstStyle/>
@@ -13265,7 +13381,7 @@
           <a:noFill/>
         </p:spPr>
         <p:txBody>
-          <a:bodyPr wrap="square" lIns="45720" rIns="45720" tIns="27432" bIns="27432" anchor="t">
+          <a:bodyPr wrap="square" lIns="45720" tIns="27432" rIns="45720" bIns="27432" anchor="t">
             <a:spAutoFit/>
           </a:bodyPr>
           <a:lstStyle/>
@@ -13300,7 +13416,7 @@
           <a:noFill/>
         </p:spPr>
         <p:txBody>
-          <a:bodyPr wrap="square" lIns="45720" rIns="45720" tIns="27432" bIns="27432" anchor="t">
+          <a:bodyPr wrap="square" lIns="45720" tIns="27432" rIns="45720" bIns="27432" anchor="t">
             <a:spAutoFit/>
           </a:bodyPr>
           <a:lstStyle/>
@@ -13356,7 +13472,7 @@
           </a:fontRef>
         </p:style>
         <p:txBody>
-          <a:bodyPr rtlCol="0" anchor="ctr" lIns="146304" rIns="146304" tIns="91440" bIns="73152"/>
+          <a:bodyPr lIns="146304" tIns="91440" rIns="146304" bIns="73152" rtlCol="0" anchor="ctr"/>
           <a:lstStyle/>
           <a:p>
             <a:pPr algn="ctr"/>
@@ -13389,7 +13505,7 @@
           <a:noFill/>
         </p:spPr>
         <p:txBody>
-          <a:bodyPr wrap="square" lIns="45720" rIns="45720" tIns="27432" bIns="27432" anchor="t">
+          <a:bodyPr wrap="square" lIns="45720" tIns="27432" rIns="45720" bIns="27432" anchor="t">
             <a:spAutoFit/>
           </a:bodyPr>
           <a:lstStyle/>
@@ -13449,6 +13565,7 @@
           <a:lstStyle/>
           <a:p>
             <a:pPr algn="ctr"/>
+            <a:endParaRPr/>
           </a:p>
         </p:txBody>
       </p:sp>
@@ -13494,6 +13611,7 @@
           <a:lstStyle/>
           <a:p>
             <a:pPr algn="ctr"/>
+            <a:endParaRPr/>
           </a:p>
         </p:txBody>
       </p:sp>
@@ -13514,7 +13632,7 @@
           <a:noFill/>
         </p:spPr>
         <p:txBody>
-          <a:bodyPr wrap="square" lIns="45720" rIns="45720" tIns="27432" bIns="27432" anchor="t">
+          <a:bodyPr wrap="square" lIns="45720" tIns="27432" rIns="45720" bIns="27432" anchor="t">
             <a:spAutoFit/>
           </a:bodyPr>
           <a:lstStyle/>
@@ -13549,7 +13667,7 @@
           <a:noFill/>
         </p:spPr>
         <p:txBody>
-          <a:bodyPr wrap="square" lIns="45720" rIns="45720" tIns="27432" bIns="27432" anchor="t">
+          <a:bodyPr wrap="square" lIns="45720" tIns="27432" rIns="45720" bIns="27432" anchor="t">
             <a:spAutoFit/>
           </a:bodyPr>
           <a:lstStyle/>
@@ -13609,6 +13727,7 @@
           <a:lstStyle/>
           <a:p>
             <a:pPr algn="ctr"/>
+            <a:endParaRPr/>
           </a:p>
         </p:txBody>
       </p:sp>
@@ -13654,6 +13773,7 @@
           <a:lstStyle/>
           <a:p>
             <a:pPr algn="ctr"/>
+            <a:endParaRPr/>
           </a:p>
         </p:txBody>
       </p:sp>
@@ -13674,7 +13794,7 @@
           <a:noFill/>
         </p:spPr>
         <p:txBody>
-          <a:bodyPr wrap="square" lIns="45720" rIns="45720" tIns="27432" bIns="27432" anchor="t">
+          <a:bodyPr wrap="square" lIns="45720" tIns="27432" rIns="45720" bIns="27432" anchor="t">
             <a:spAutoFit/>
           </a:bodyPr>
           <a:lstStyle/>
@@ -13709,7 +13829,7 @@
           <a:noFill/>
         </p:spPr>
         <p:txBody>
-          <a:bodyPr wrap="square" lIns="45720" rIns="45720" tIns="27432" bIns="27432" anchor="t">
+          <a:bodyPr wrap="square" lIns="45720" tIns="27432" rIns="45720" bIns="27432" anchor="t">
             <a:spAutoFit/>
           </a:bodyPr>
           <a:lstStyle/>
@@ -13769,6 +13889,7 @@
           <a:lstStyle/>
           <a:p>
             <a:pPr algn="ctr"/>
+            <a:endParaRPr/>
           </a:p>
         </p:txBody>
       </p:sp>
@@ -13814,6 +13935,7 @@
           <a:lstStyle/>
           <a:p>
             <a:pPr algn="ctr"/>
+            <a:endParaRPr/>
           </a:p>
         </p:txBody>
       </p:sp>
@@ -13834,7 +13956,7 @@
           <a:noFill/>
         </p:spPr>
         <p:txBody>
-          <a:bodyPr wrap="square" lIns="45720" rIns="45720" tIns="27432" bIns="27432" anchor="t">
+          <a:bodyPr wrap="square" lIns="45720" tIns="27432" rIns="45720" bIns="27432" anchor="t">
             <a:spAutoFit/>
           </a:bodyPr>
           <a:lstStyle/>
@@ -13890,7 +14012,7 @@
           </a:fontRef>
         </p:style>
         <p:txBody>
-          <a:bodyPr rtlCol="0" anchor="ctr" lIns="146304" rIns="146304" tIns="91440" bIns="73152"/>
+          <a:bodyPr lIns="146304" tIns="91440" rIns="146304" bIns="73152" rtlCol="0" anchor="ctr"/>
           <a:lstStyle/>
           <a:p>
             <a:pPr algn="ctr"/>
@@ -13923,7 +14045,7 @@
           <a:noFill/>
         </p:spPr>
         <p:txBody>
-          <a:bodyPr wrap="square" lIns="45720" rIns="45720" tIns="27432" bIns="27432" anchor="t">
+          <a:bodyPr wrap="square" lIns="45720" tIns="27432" rIns="45720" bIns="27432" anchor="t">
             <a:spAutoFit/>
           </a:bodyPr>
           <a:lstStyle/>
@@ -13983,6 +14105,7 @@
           <a:lstStyle/>
           <a:p>
             <a:pPr algn="ctr"/>
+            <a:endParaRPr/>
           </a:p>
         </p:txBody>
       </p:sp>
@@ -14028,6 +14151,7 @@
           <a:lstStyle/>
           <a:p>
             <a:pPr algn="ctr"/>
+            <a:endParaRPr/>
           </a:p>
         </p:txBody>
       </p:sp>
@@ -14048,7 +14172,7 @@
           <a:noFill/>
         </p:spPr>
         <p:txBody>
-          <a:bodyPr wrap="square" lIns="45720" rIns="45720" tIns="27432" bIns="27432" anchor="t">
+          <a:bodyPr wrap="square" lIns="45720" tIns="27432" rIns="45720" bIns="27432" anchor="t">
             <a:spAutoFit/>
           </a:bodyPr>
           <a:lstStyle/>
@@ -14083,7 +14207,7 @@
           <a:noFill/>
         </p:spPr>
         <p:txBody>
-          <a:bodyPr wrap="square" lIns="45720" rIns="45720" tIns="27432" bIns="27432" anchor="t">
+          <a:bodyPr wrap="square" lIns="45720" tIns="27432" rIns="45720" bIns="27432" anchor="t">
             <a:spAutoFit/>
           </a:bodyPr>
           <a:lstStyle/>
@@ -14143,6 +14267,7 @@
           <a:lstStyle/>
           <a:p>
             <a:pPr algn="ctr"/>
+            <a:endParaRPr/>
           </a:p>
         </p:txBody>
       </p:sp>
@@ -14188,6 +14313,7 @@
           <a:lstStyle/>
           <a:p>
             <a:pPr algn="ctr"/>
+            <a:endParaRPr/>
           </a:p>
         </p:txBody>
       </p:sp>
@@ -14208,7 +14334,7 @@
           <a:noFill/>
         </p:spPr>
         <p:txBody>
-          <a:bodyPr wrap="square" lIns="45720" rIns="45720" tIns="27432" bIns="27432" anchor="t">
+          <a:bodyPr wrap="square" lIns="45720" tIns="27432" rIns="45720" bIns="27432" anchor="t">
             <a:spAutoFit/>
           </a:bodyPr>
           <a:lstStyle/>
@@ -14243,7 +14369,7 @@
           <a:noFill/>
         </p:spPr>
         <p:txBody>
-          <a:bodyPr wrap="square" lIns="45720" rIns="45720" tIns="27432" bIns="27432" anchor="t">
+          <a:bodyPr wrap="square" lIns="45720" tIns="27432" rIns="45720" bIns="27432" anchor="t">
             <a:spAutoFit/>
           </a:bodyPr>
           <a:lstStyle/>
@@ -14303,6 +14429,7 @@
           <a:lstStyle/>
           <a:p>
             <a:pPr algn="ctr"/>
+            <a:endParaRPr/>
           </a:p>
         </p:txBody>
       </p:sp>
@@ -14348,6 +14475,7 @@
           <a:lstStyle/>
           <a:p>
             <a:pPr algn="ctr"/>
+            <a:endParaRPr/>
           </a:p>
         </p:txBody>
       </p:sp>
@@ -14368,7 +14496,7 @@
           <a:noFill/>
         </p:spPr>
         <p:txBody>
-          <a:bodyPr wrap="square" lIns="45720" rIns="45720" tIns="27432" bIns="27432" anchor="t">
+          <a:bodyPr wrap="square" lIns="45720" tIns="27432" rIns="45720" bIns="27432" anchor="t">
             <a:spAutoFit/>
           </a:bodyPr>
           <a:lstStyle/>
@@ -14395,7 +14523,7 @@
 </file>
 
 <file path=ppt/slides/slide6.xml><?xml version="1.0" encoding="utf-8"?>
-<p:sld xmlns:a="http://schemas.openxmlformats.org/drawingml/2006/main" xmlns:p="http://schemas.openxmlformats.org/presentationml/2006/main" xmlns:r="http://schemas.openxmlformats.org/officeDocument/2006/relationships">
+<p:sld xmlns:a="http://schemas.openxmlformats.org/drawingml/2006/main" xmlns:r="http://schemas.openxmlformats.org/officeDocument/2006/relationships" xmlns:p="http://schemas.openxmlformats.org/presentationml/2006/main">
   <p:cSld>
     <p:bg>
       <p:bgPr>
@@ -14411,7 +14539,14 @@
         <p:cNvGrpSpPr/>
         <p:nvPr/>
       </p:nvGrpSpPr>
-      <p:grpSpPr/>
+      <p:grpSpPr>
+        <a:xfrm>
+          <a:off x="0" y="0"/>
+          <a:ext cx="0" cy="0"/>
+          <a:chOff x="0" y="0"/>
+          <a:chExt cx="0" cy="0"/>
+        </a:xfrm>
+      </p:grpSpPr>
       <p:sp>
         <p:nvSpPr>
           <p:cNvPr id="2" name="TextBox 1"/>
@@ -14429,7 +14564,7 @@
           <a:noFill/>
         </p:spPr>
         <p:txBody>
-          <a:bodyPr wrap="square" lIns="45720" rIns="45720" tIns="27432" bIns="27432" anchor="t">
+          <a:bodyPr wrap="square" lIns="45720" tIns="27432" rIns="45720" bIns="27432" anchor="t">
             <a:spAutoFit/>
           </a:bodyPr>
           <a:lstStyle/>
@@ -14464,7 +14599,7 @@
           <a:noFill/>
         </p:spPr>
         <p:txBody>
-          <a:bodyPr wrap="square" lIns="45720" rIns="45720" tIns="27432" bIns="27432" anchor="t">
+          <a:bodyPr wrap="square" lIns="45720" tIns="27432" rIns="45720" bIns="27432" anchor="t">
             <a:spAutoFit/>
           </a:bodyPr>
           <a:lstStyle/>
@@ -14503,7 +14638,7 @@
           <a:noFill/>
         </p:spPr>
         <p:txBody>
-          <a:bodyPr wrap="square" lIns="45720" rIns="45720" tIns="27432" bIns="27432" anchor="t">
+          <a:bodyPr wrap="square" lIns="45720" tIns="27432" rIns="45720" bIns="27432" anchor="t">
             <a:spAutoFit/>
           </a:bodyPr>
           <a:lstStyle/>
@@ -14559,7 +14694,7 @@
           </a:fontRef>
         </p:style>
         <p:txBody>
-          <a:bodyPr rtlCol="0" anchor="ctr" lIns="146304" rIns="146304" tIns="91440" bIns="73152"/>
+          <a:bodyPr lIns="146304" tIns="91440" rIns="146304" bIns="73152" rtlCol="0" anchor="ctr"/>
           <a:lstStyle/>
           <a:p>
             <a:pPr algn="ctr"/>
@@ -14592,7 +14727,7 @@
           <a:noFill/>
         </p:spPr>
         <p:txBody>
-          <a:bodyPr wrap="square" lIns="45720" rIns="45720" tIns="27432" bIns="27432" anchor="t">
+          <a:bodyPr wrap="square" lIns="45720" tIns="27432" rIns="45720" bIns="27432" anchor="t">
             <a:spAutoFit/>
           </a:bodyPr>
           <a:lstStyle/>
@@ -14652,6 +14787,7 @@
           <a:lstStyle/>
           <a:p>
             <a:pPr algn="ctr"/>
+            <a:endParaRPr/>
           </a:p>
         </p:txBody>
       </p:sp>
@@ -14697,6 +14833,7 @@
           <a:lstStyle/>
           <a:p>
             <a:pPr algn="ctr"/>
+            <a:endParaRPr/>
           </a:p>
         </p:txBody>
       </p:sp>
@@ -14717,7 +14854,7 @@
           <a:noFill/>
         </p:spPr>
         <p:txBody>
-          <a:bodyPr wrap="square" lIns="45720" rIns="45720" tIns="27432" bIns="27432" anchor="t">
+          <a:bodyPr wrap="square" lIns="45720" tIns="27432" rIns="45720" bIns="27432" anchor="t">
             <a:spAutoFit/>
           </a:bodyPr>
           <a:lstStyle/>
@@ -14752,7 +14889,7 @@
           <a:noFill/>
         </p:spPr>
         <p:txBody>
-          <a:bodyPr wrap="square" lIns="45720" rIns="45720" tIns="27432" bIns="27432" anchor="t">
+          <a:bodyPr wrap="square" lIns="45720" tIns="27432" rIns="45720" bIns="27432" anchor="t">
             <a:spAutoFit/>
           </a:bodyPr>
           <a:lstStyle/>
@@ -14812,6 +14949,7 @@
           <a:lstStyle/>
           <a:p>
             <a:pPr algn="ctr"/>
+            <a:endParaRPr/>
           </a:p>
         </p:txBody>
       </p:sp>
@@ -14857,6 +14995,7 @@
           <a:lstStyle/>
           <a:p>
             <a:pPr algn="ctr"/>
+            <a:endParaRPr/>
           </a:p>
         </p:txBody>
       </p:sp>
@@ -14877,7 +15016,7 @@
           <a:noFill/>
         </p:spPr>
         <p:txBody>
-          <a:bodyPr wrap="square" lIns="45720" rIns="45720" tIns="27432" bIns="27432" anchor="t">
+          <a:bodyPr wrap="square" lIns="45720" tIns="27432" rIns="45720" bIns="27432" anchor="t">
             <a:spAutoFit/>
           </a:bodyPr>
           <a:lstStyle/>
@@ -14912,7 +15051,7 @@
           <a:noFill/>
         </p:spPr>
         <p:txBody>
-          <a:bodyPr wrap="square" lIns="45720" rIns="45720" tIns="27432" bIns="27432" anchor="t">
+          <a:bodyPr wrap="square" lIns="45720" tIns="27432" rIns="45720" bIns="27432" anchor="t">
             <a:spAutoFit/>
           </a:bodyPr>
           <a:lstStyle/>
@@ -14972,6 +15111,7 @@
           <a:lstStyle/>
           <a:p>
             <a:pPr algn="ctr"/>
+            <a:endParaRPr/>
           </a:p>
         </p:txBody>
       </p:sp>
@@ -15017,6 +15157,7 @@
           <a:lstStyle/>
           <a:p>
             <a:pPr algn="ctr"/>
+            <a:endParaRPr/>
           </a:p>
         </p:txBody>
       </p:sp>
@@ -15037,7 +15178,7 @@
           <a:noFill/>
         </p:spPr>
         <p:txBody>
-          <a:bodyPr wrap="square" lIns="45720" rIns="45720" tIns="27432" bIns="27432" anchor="t">
+          <a:bodyPr wrap="square" lIns="45720" tIns="27432" rIns="45720" bIns="27432" anchor="t">
             <a:spAutoFit/>
           </a:bodyPr>
           <a:lstStyle/>
@@ -15093,7 +15234,7 @@
           </a:fontRef>
         </p:style>
         <p:txBody>
-          <a:bodyPr rtlCol="0" anchor="ctr" lIns="146304" rIns="146304" tIns="91440" bIns="73152"/>
+          <a:bodyPr lIns="146304" tIns="91440" rIns="146304" bIns="73152" rtlCol="0" anchor="ctr"/>
           <a:lstStyle/>
           <a:p>
             <a:pPr algn="ctr"/>
@@ -15126,7 +15267,7 @@
           <a:noFill/>
         </p:spPr>
         <p:txBody>
-          <a:bodyPr wrap="square" lIns="45720" rIns="45720" tIns="27432" bIns="27432" anchor="t">
+          <a:bodyPr wrap="square" lIns="45720" tIns="27432" rIns="45720" bIns="27432" anchor="t">
             <a:spAutoFit/>
           </a:bodyPr>
           <a:lstStyle/>
@@ -15186,6 +15327,7 @@
           <a:lstStyle/>
           <a:p>
             <a:pPr algn="ctr"/>
+            <a:endParaRPr/>
           </a:p>
         </p:txBody>
       </p:sp>
@@ -15231,6 +15373,7 @@
           <a:lstStyle/>
           <a:p>
             <a:pPr algn="ctr"/>
+            <a:endParaRPr/>
           </a:p>
         </p:txBody>
       </p:sp>
@@ -15251,7 +15394,7 @@
           <a:noFill/>
         </p:spPr>
         <p:txBody>
-          <a:bodyPr wrap="square" lIns="45720" rIns="45720" tIns="27432" bIns="27432" anchor="t">
+          <a:bodyPr wrap="square" lIns="45720" tIns="27432" rIns="45720" bIns="27432" anchor="t">
             <a:spAutoFit/>
           </a:bodyPr>
           <a:lstStyle/>
@@ -15286,7 +15429,7 @@
           <a:noFill/>
         </p:spPr>
         <p:txBody>
-          <a:bodyPr wrap="square" lIns="45720" rIns="45720" tIns="27432" bIns="27432" anchor="t">
+          <a:bodyPr wrap="square" lIns="45720" tIns="27432" rIns="45720" bIns="27432" anchor="t">
             <a:spAutoFit/>
           </a:bodyPr>
           <a:lstStyle/>
@@ -15346,6 +15489,7 @@
           <a:lstStyle/>
           <a:p>
             <a:pPr algn="ctr"/>
+            <a:endParaRPr/>
           </a:p>
         </p:txBody>
       </p:sp>
@@ -15391,6 +15535,7 @@
           <a:lstStyle/>
           <a:p>
             <a:pPr algn="ctr"/>
+            <a:endParaRPr/>
           </a:p>
         </p:txBody>
       </p:sp>
@@ -15411,7 +15556,7 @@
           <a:noFill/>
         </p:spPr>
         <p:txBody>
-          <a:bodyPr wrap="square" lIns="45720" rIns="45720" tIns="27432" bIns="27432" anchor="t">
+          <a:bodyPr wrap="square" lIns="45720" tIns="27432" rIns="45720" bIns="27432" anchor="t">
             <a:spAutoFit/>
           </a:bodyPr>
           <a:lstStyle/>
@@ -15446,7 +15591,7 @@
           <a:noFill/>
         </p:spPr>
         <p:txBody>
-          <a:bodyPr wrap="square" lIns="45720" rIns="45720" tIns="27432" bIns="27432" anchor="t">
+          <a:bodyPr wrap="square" lIns="45720" tIns="27432" rIns="45720" bIns="27432" anchor="t">
             <a:spAutoFit/>
           </a:bodyPr>
           <a:lstStyle/>
@@ -15506,6 +15651,7 @@
           <a:lstStyle/>
           <a:p>
             <a:pPr algn="ctr"/>
+            <a:endParaRPr/>
           </a:p>
         </p:txBody>
       </p:sp>
@@ -15551,6 +15697,7 @@
           <a:lstStyle/>
           <a:p>
             <a:pPr algn="ctr"/>
+            <a:endParaRPr/>
           </a:p>
         </p:txBody>
       </p:sp>
@@ -15571,7 +15718,7 @@
           <a:noFill/>
         </p:spPr>
         <p:txBody>
-          <a:bodyPr wrap="square" lIns="45720" rIns="45720" tIns="27432" bIns="27432" anchor="t">
+          <a:bodyPr wrap="square" lIns="45720" tIns="27432" rIns="45720" bIns="27432" anchor="t">
             <a:spAutoFit/>
           </a:bodyPr>
           <a:lstStyle/>
@@ -15627,7 +15774,7 @@
           </a:fontRef>
         </p:style>
         <p:txBody>
-          <a:bodyPr rtlCol="0" anchor="ctr" lIns="146304" rIns="146304" tIns="91440" bIns="73152"/>
+          <a:bodyPr lIns="146304" tIns="91440" rIns="146304" bIns="73152" rtlCol="0" anchor="ctr"/>
           <a:lstStyle/>
           <a:p>
             <a:pPr algn="ctr"/>
@@ -15685,6 +15832,7 @@
           <a:lstStyle/>
           <a:p>
             <a:pPr algn="ctr"/>
+            <a:endParaRPr/>
           </a:p>
         </p:txBody>
       </p:sp>
@@ -15705,7 +15853,7 @@
           <a:noFill/>
         </p:spPr>
         <p:txBody>
-          <a:bodyPr wrap="square" lIns="45720" rIns="45720" tIns="27432" bIns="27432" anchor="t">
+          <a:bodyPr wrap="square" lIns="45720" tIns="27432" rIns="45720" bIns="27432" anchor="t">
             <a:spAutoFit/>
           </a:bodyPr>
           <a:lstStyle/>
@@ -15740,7 +15888,7 @@
           <a:noFill/>
         </p:spPr>
         <p:txBody>
-          <a:bodyPr wrap="square" lIns="45720" rIns="45720" tIns="27432" bIns="27432" anchor="t">
+          <a:bodyPr wrap="square" lIns="45720" tIns="27432" rIns="45720" bIns="27432" anchor="t">
             <a:spAutoFit/>
           </a:bodyPr>
           <a:lstStyle/>
@@ -15775,7 +15923,7 @@
           <a:noFill/>
         </p:spPr>
         <p:txBody>
-          <a:bodyPr wrap="square" lIns="45720" rIns="45720" tIns="27432" bIns="27432" anchor="t">
+          <a:bodyPr wrap="square" lIns="45720" tIns="27432" rIns="45720" bIns="27432" anchor="t">
             <a:spAutoFit/>
           </a:bodyPr>
           <a:lstStyle/>
@@ -15835,6 +15983,7 @@
           <a:lstStyle/>
           <a:p>
             <a:pPr algn="ctr"/>
+            <a:endParaRPr/>
           </a:p>
         </p:txBody>
       </p:sp>
@@ -15855,7 +16004,7 @@
           <a:noFill/>
         </p:spPr>
         <p:txBody>
-          <a:bodyPr wrap="square" lIns="45720" rIns="45720" tIns="27432" bIns="27432" anchor="t">
+          <a:bodyPr wrap="square" lIns="45720" tIns="27432" rIns="45720" bIns="27432" anchor="t">
             <a:spAutoFit/>
           </a:bodyPr>
           <a:lstStyle/>
@@ -15890,7 +16039,7 @@
           <a:noFill/>
         </p:spPr>
         <p:txBody>
-          <a:bodyPr wrap="square" lIns="45720" rIns="45720" tIns="27432" bIns="27432" anchor="t">
+          <a:bodyPr wrap="square" lIns="45720" tIns="27432" rIns="45720" bIns="27432" anchor="t">
             <a:spAutoFit/>
           </a:bodyPr>
           <a:lstStyle/>
@@ -15925,7 +16074,7 @@
           <a:noFill/>
         </p:spPr>
         <p:txBody>
-          <a:bodyPr wrap="square" lIns="45720" rIns="45720" tIns="27432" bIns="27432" anchor="t">
+          <a:bodyPr wrap="square" lIns="45720" tIns="27432" rIns="45720" bIns="27432" anchor="t">
             <a:spAutoFit/>
           </a:bodyPr>
           <a:lstStyle/>
@@ -15985,6 +16134,7 @@
           <a:lstStyle/>
           <a:p>
             <a:pPr algn="ctr"/>
+            <a:endParaRPr/>
           </a:p>
         </p:txBody>
       </p:sp>
@@ -16005,7 +16155,7 @@
           <a:noFill/>
         </p:spPr>
         <p:txBody>
-          <a:bodyPr wrap="square" lIns="45720" rIns="45720" tIns="27432" bIns="27432" anchor="t">
+          <a:bodyPr wrap="square" lIns="45720" tIns="27432" rIns="45720" bIns="27432" anchor="t">
             <a:spAutoFit/>
           </a:bodyPr>
           <a:lstStyle/>
@@ -16040,7 +16190,7 @@
           <a:noFill/>
         </p:spPr>
         <p:txBody>
-          <a:bodyPr wrap="square" lIns="45720" rIns="45720" tIns="27432" bIns="27432" anchor="t">
+          <a:bodyPr wrap="square" lIns="45720" tIns="27432" rIns="45720" bIns="27432" anchor="t">
             <a:spAutoFit/>
           </a:bodyPr>
           <a:lstStyle/>
@@ -16075,7 +16225,7 @@
           <a:noFill/>
         </p:spPr>
         <p:txBody>
-          <a:bodyPr wrap="square" lIns="45720" rIns="45720" tIns="27432" bIns="27432" anchor="t">
+          <a:bodyPr wrap="square" lIns="45720" tIns="27432" rIns="45720" bIns="27432" anchor="t">
             <a:spAutoFit/>
           </a:bodyPr>
           <a:lstStyle/>
@@ -16135,6 +16285,7 @@
           <a:lstStyle/>
           <a:p>
             <a:pPr algn="ctr"/>
+            <a:endParaRPr/>
           </a:p>
         </p:txBody>
       </p:sp>
@@ -16155,7 +16306,7 @@
           <a:noFill/>
         </p:spPr>
         <p:txBody>
-          <a:bodyPr wrap="square" lIns="45720" rIns="45720" tIns="27432" bIns="27432" anchor="t">
+          <a:bodyPr wrap="square" lIns="45720" tIns="27432" rIns="45720" bIns="27432" anchor="t">
             <a:spAutoFit/>
           </a:bodyPr>
           <a:lstStyle/>
@@ -16190,7 +16341,7 @@
           <a:noFill/>
         </p:spPr>
         <p:txBody>
-          <a:bodyPr wrap="square" lIns="45720" rIns="45720" tIns="27432" bIns="27432" anchor="t">
+          <a:bodyPr wrap="square" lIns="45720" tIns="27432" rIns="45720" bIns="27432" anchor="t">
             <a:spAutoFit/>
           </a:bodyPr>
           <a:lstStyle/>
@@ -16246,7 +16397,7 @@
           </a:fontRef>
         </p:style>
         <p:txBody>
-          <a:bodyPr rtlCol="0" anchor="ctr" lIns="146304" rIns="146304" tIns="91440" bIns="73152"/>
+          <a:bodyPr lIns="146304" tIns="91440" rIns="146304" bIns="73152" rtlCol="0" anchor="ctr"/>
           <a:lstStyle/>
           <a:p>
             <a:pPr algn="ctr"/>
@@ -16287,7 +16438,7 @@
 </file>
 
 <file path=ppt/slides/slide7.xml><?xml version="1.0" encoding="utf-8"?>
-<p:sld xmlns:a="http://schemas.openxmlformats.org/drawingml/2006/main" xmlns:p="http://schemas.openxmlformats.org/presentationml/2006/main" xmlns:r="http://schemas.openxmlformats.org/officeDocument/2006/relationships">
+<p:sld xmlns:a="http://schemas.openxmlformats.org/drawingml/2006/main" xmlns:r="http://schemas.openxmlformats.org/officeDocument/2006/relationships" xmlns:p="http://schemas.openxmlformats.org/presentationml/2006/main">
   <p:cSld>
     <p:bg>
       <p:bgPr>
@@ -16303,7 +16454,14 @@
         <p:cNvGrpSpPr/>
         <p:nvPr/>
       </p:nvGrpSpPr>
-      <p:grpSpPr/>
+      <p:grpSpPr>
+        <a:xfrm>
+          <a:off x="0" y="0"/>
+          <a:ext cx="0" cy="0"/>
+          <a:chOff x="0" y="0"/>
+          <a:chExt cx="0" cy="0"/>
+        </a:xfrm>
+      </p:grpSpPr>
       <p:sp>
         <p:nvSpPr>
           <p:cNvPr id="2" name="TextBox 1"/>
@@ -16321,7 +16479,7 @@
           <a:noFill/>
         </p:spPr>
         <p:txBody>
-          <a:bodyPr wrap="square" lIns="45720" rIns="45720" tIns="27432" bIns="27432" anchor="t">
+          <a:bodyPr wrap="square" lIns="45720" tIns="27432" rIns="45720" bIns="27432" anchor="t">
             <a:spAutoFit/>
           </a:bodyPr>
           <a:lstStyle/>
@@ -16356,7 +16514,7 @@
           <a:noFill/>
         </p:spPr>
         <p:txBody>
-          <a:bodyPr wrap="square" lIns="45720" rIns="45720" tIns="27432" bIns="27432" anchor="t">
+          <a:bodyPr wrap="square" lIns="45720" tIns="27432" rIns="45720" bIns="27432" anchor="t">
             <a:spAutoFit/>
           </a:bodyPr>
           <a:lstStyle/>
@@ -16395,7 +16553,7 @@
           <a:noFill/>
         </p:spPr>
         <p:txBody>
-          <a:bodyPr wrap="square" lIns="45720" rIns="45720" tIns="27432" bIns="27432" anchor="t">
+          <a:bodyPr wrap="square" lIns="45720" tIns="27432" rIns="45720" bIns="27432" anchor="t">
             <a:spAutoFit/>
           </a:bodyPr>
           <a:lstStyle/>
@@ -16451,7 +16609,7 @@
           </a:fontRef>
         </p:style>
         <p:txBody>
-          <a:bodyPr rtlCol="0" anchor="ctr" lIns="146304" rIns="146304" tIns="91440" bIns="73152"/>
+          <a:bodyPr lIns="146304" tIns="91440" rIns="146304" bIns="73152" rtlCol="0" anchor="ctr"/>
           <a:lstStyle/>
           <a:p>
             <a:pPr algn="ctr"/>
@@ -16521,7 +16679,7 @@
           </a:fontRef>
         </p:style>
         <p:txBody>
-          <a:bodyPr rtlCol="0" anchor="ctr" lIns="146304" rIns="146304" tIns="91440" bIns="73152"/>
+          <a:bodyPr lIns="146304" tIns="91440" rIns="146304" bIns="73152" rtlCol="0" anchor="ctr"/>
           <a:lstStyle/>
           <a:p>
             <a:pPr algn="ctr"/>
@@ -16591,7 +16749,7 @@
           </a:fontRef>
         </p:style>
         <p:txBody>
-          <a:bodyPr rtlCol="0" anchor="ctr" wrap="square" lIns="164592" rIns="164592" tIns="109728" bIns="91440"/>
+          <a:bodyPr wrap="square" lIns="164592" tIns="109728" rIns="164592" bIns="91440" rtlCol="0" anchor="ctr"/>
           <a:lstStyle/>
           <a:p>
             <a:pPr algn="ctr"/>
@@ -16693,7 +16851,7 @@
           </a:fontRef>
         </p:style>
         <p:txBody>
-          <a:bodyPr rtlCol="0" anchor="ctr" wrap="square" lIns="164592" rIns="164592" tIns="109728" bIns="91440"/>
+          <a:bodyPr wrap="square" lIns="164592" tIns="109728" rIns="164592" bIns="91440" rtlCol="0" anchor="ctr"/>
           <a:lstStyle/>
           <a:p>
             <a:pPr algn="ctr"/>
@@ -16795,7 +16953,7 @@
           </a:fontRef>
         </p:style>
         <p:txBody>
-          <a:bodyPr rtlCol="0" anchor="ctr" wrap="square" lIns="164592" rIns="164592" tIns="109728" bIns="91440"/>
+          <a:bodyPr wrap="square" lIns="164592" tIns="109728" rIns="164592" bIns="91440" rtlCol="0" anchor="ctr"/>
           <a:lstStyle/>
           <a:p>
             <a:pPr algn="ctr"/>
@@ -16868,7 +17026,7 @@
 </file>
 
 <file path=ppt/slides/slide8.xml><?xml version="1.0" encoding="utf-8"?>
-<p:sld xmlns:a="http://schemas.openxmlformats.org/drawingml/2006/main" xmlns:p="http://schemas.openxmlformats.org/presentationml/2006/main" xmlns:r="http://schemas.openxmlformats.org/officeDocument/2006/relationships">
+<p:sld xmlns:a="http://schemas.openxmlformats.org/drawingml/2006/main" xmlns:r="http://schemas.openxmlformats.org/officeDocument/2006/relationships" xmlns:p="http://schemas.openxmlformats.org/presentationml/2006/main">
   <p:cSld>
     <p:bg>
       <p:bgPr>
@@ -16884,7 +17042,14 @@
         <p:cNvGrpSpPr/>
         <p:nvPr/>
       </p:nvGrpSpPr>
-      <p:grpSpPr/>
+      <p:grpSpPr>
+        <a:xfrm>
+          <a:off x="0" y="0"/>
+          <a:ext cx="0" cy="0"/>
+          <a:chOff x="0" y="0"/>
+          <a:chExt cx="0" cy="0"/>
+        </a:xfrm>
+      </p:grpSpPr>
       <p:sp>
         <p:nvSpPr>
           <p:cNvPr id="2" name="TextBox 1"/>
@@ -16902,7 +17067,7 @@
           <a:noFill/>
         </p:spPr>
         <p:txBody>
-          <a:bodyPr wrap="square" lIns="45720" rIns="45720" tIns="27432" bIns="27432" anchor="t">
+          <a:bodyPr wrap="square" lIns="45720" tIns="27432" rIns="45720" bIns="27432" anchor="t">
             <a:spAutoFit/>
           </a:bodyPr>
           <a:lstStyle/>
@@ -16937,7 +17102,7 @@
           <a:noFill/>
         </p:spPr>
         <p:txBody>
-          <a:bodyPr wrap="square" lIns="45720" rIns="45720" tIns="27432" bIns="27432" anchor="t">
+          <a:bodyPr wrap="square" lIns="45720" tIns="27432" rIns="45720" bIns="27432" anchor="t">
             <a:spAutoFit/>
           </a:bodyPr>
           <a:lstStyle/>
@@ -16972,7 +17137,7 @@
           <a:noFill/>
         </p:spPr>
         <p:txBody>
-          <a:bodyPr wrap="square" lIns="45720" rIns="45720" tIns="27432" bIns="27432" anchor="t">
+          <a:bodyPr wrap="square" lIns="45720" tIns="27432" rIns="45720" bIns="27432" anchor="t">
             <a:spAutoFit/>
           </a:bodyPr>
           <a:lstStyle/>
@@ -17028,7 +17193,7 @@
           </a:fontRef>
         </p:style>
         <p:txBody>
-          <a:bodyPr rtlCol="0" anchor="ctr" wrap="square" lIns="164592" rIns="164592" tIns="109728" bIns="91440"/>
+          <a:bodyPr wrap="square" lIns="164592" tIns="109728" rIns="164592" bIns="91440" rtlCol="0" anchor="ctr"/>
           <a:lstStyle/>
           <a:p>
             <a:pPr algn="ctr"/>
@@ -17146,7 +17311,7 @@
           </a:fontRef>
         </p:style>
         <p:txBody>
-          <a:bodyPr rtlCol="0" anchor="ctr" lIns="146304" rIns="146304" tIns="91440" bIns="73152"/>
+          <a:bodyPr lIns="146304" tIns="91440" rIns="146304" bIns="73152" rtlCol="0" anchor="ctr"/>
           <a:lstStyle/>
           <a:p>
             <a:pPr algn="ctr"/>
@@ -17179,7 +17344,7 @@
           <a:noFill/>
         </p:spPr>
         <p:txBody>
-          <a:bodyPr wrap="square" lIns="45720" rIns="45720" tIns="27432" bIns="27432" anchor="t">
+          <a:bodyPr wrap="square" lIns="45720" tIns="27432" rIns="45720" bIns="27432" anchor="t">
             <a:spAutoFit/>
           </a:bodyPr>
           <a:lstStyle/>
@@ -17214,7 +17379,7 @@
           <a:noFill/>
         </p:spPr>
         <p:txBody>
-          <a:bodyPr wrap="square" lIns="45720" rIns="45720" tIns="27432" bIns="27432" anchor="t">
+          <a:bodyPr wrap="square" lIns="45720" tIns="27432" rIns="45720" bIns="27432" anchor="t">
             <a:spAutoFit/>
           </a:bodyPr>
           <a:lstStyle/>
@@ -17249,7 +17414,7 @@
           <a:noFill/>
         </p:spPr>
         <p:txBody>
-          <a:bodyPr wrap="square" lIns="45720" rIns="45720" tIns="27432" bIns="27432" anchor="t">
+          <a:bodyPr wrap="square" lIns="45720" tIns="27432" rIns="45720" bIns="27432" anchor="t">
             <a:spAutoFit/>
           </a:bodyPr>
           <a:lstStyle/>
@@ -17284,7 +17449,7 @@
           <a:noFill/>
         </p:spPr>
         <p:txBody>
-          <a:bodyPr wrap="square" lIns="45720" rIns="45720" tIns="27432" bIns="27432" anchor="t">
+          <a:bodyPr wrap="square" lIns="45720" tIns="27432" rIns="45720" bIns="27432" anchor="t">
             <a:spAutoFit/>
           </a:bodyPr>
           <a:lstStyle/>
@@ -17319,7 +17484,7 @@
           <a:noFill/>
         </p:spPr>
         <p:txBody>
-          <a:bodyPr wrap="square" lIns="45720" rIns="45720" tIns="27432" bIns="27432" anchor="t">
+          <a:bodyPr wrap="square" lIns="45720" tIns="27432" rIns="45720" bIns="27432" anchor="t">
             <a:spAutoFit/>
           </a:bodyPr>
           <a:lstStyle/>
@@ -17354,7 +17519,7 @@
           <a:noFill/>
         </p:spPr>
         <p:txBody>
-          <a:bodyPr wrap="square" lIns="45720" rIns="45720" tIns="27432" bIns="27432" anchor="t">
+          <a:bodyPr wrap="square" lIns="45720" tIns="27432" rIns="45720" bIns="27432" anchor="t">
             <a:spAutoFit/>
           </a:bodyPr>
           <a:lstStyle/>
@@ -17389,7 +17554,7 @@
           <a:noFill/>
         </p:spPr>
         <p:txBody>
-          <a:bodyPr wrap="square" lIns="45720" rIns="45720" tIns="27432" bIns="27432" anchor="t">
+          <a:bodyPr wrap="square" lIns="45720" tIns="27432" rIns="45720" bIns="27432" anchor="t">
             <a:spAutoFit/>
           </a:bodyPr>
           <a:lstStyle/>
@@ -17424,7 +17589,7 @@
           <a:noFill/>
         </p:spPr>
         <p:txBody>
-          <a:bodyPr wrap="square" lIns="45720" rIns="45720" tIns="27432" bIns="27432" anchor="t">
+          <a:bodyPr wrap="square" lIns="45720" tIns="27432" rIns="45720" bIns="27432" anchor="t">
             <a:spAutoFit/>
           </a:bodyPr>
           <a:lstStyle/>
@@ -17480,7 +17645,7 @@
           </a:fontRef>
         </p:style>
         <p:txBody>
-          <a:bodyPr rtlCol="0" anchor="ctr" lIns="146304" rIns="146304" tIns="91440" bIns="73152"/>
+          <a:bodyPr lIns="146304" tIns="91440" rIns="146304" bIns="73152" rtlCol="0" anchor="ctr"/>
           <a:lstStyle/>
           <a:p>
             <a:pPr algn="ctr"/>
@@ -17513,7 +17678,7 @@
           <a:noFill/>
         </p:spPr>
         <p:txBody>
-          <a:bodyPr wrap="square" lIns="45720" rIns="45720" tIns="27432" bIns="27432" anchor="t">
+          <a:bodyPr wrap="square" lIns="45720" tIns="27432" rIns="45720" bIns="27432" anchor="t">
             <a:spAutoFit/>
           </a:bodyPr>
           <a:lstStyle/>
@@ -17573,6 +17738,7 @@
           <a:lstStyle/>
           <a:p>
             <a:pPr algn="ctr"/>
+            <a:endParaRPr/>
           </a:p>
         </p:txBody>
       </p:sp>
@@ -17618,6 +17784,7 @@
           <a:lstStyle/>
           <a:p>
             <a:pPr algn="ctr"/>
+            <a:endParaRPr/>
           </a:p>
         </p:txBody>
       </p:sp>
@@ -17638,7 +17805,7 @@
           <a:noFill/>
         </p:spPr>
         <p:txBody>
-          <a:bodyPr wrap="square" lIns="45720" rIns="45720" tIns="27432" bIns="27432" anchor="t">
+          <a:bodyPr wrap="square" lIns="45720" tIns="27432" rIns="45720" bIns="27432" anchor="t">
             <a:spAutoFit/>
           </a:bodyPr>
           <a:lstStyle/>
@@ -17673,7 +17840,7 @@
           <a:noFill/>
         </p:spPr>
         <p:txBody>
-          <a:bodyPr wrap="square" lIns="45720" rIns="45720" tIns="27432" bIns="27432" anchor="t">
+          <a:bodyPr wrap="square" lIns="45720" tIns="27432" rIns="45720" bIns="27432" anchor="t">
             <a:spAutoFit/>
           </a:bodyPr>
           <a:lstStyle/>
@@ -17733,6 +17900,7 @@
           <a:lstStyle/>
           <a:p>
             <a:pPr algn="ctr"/>
+            <a:endParaRPr/>
           </a:p>
         </p:txBody>
       </p:sp>
@@ -17778,6 +17946,7 @@
           <a:lstStyle/>
           <a:p>
             <a:pPr algn="ctr"/>
+            <a:endParaRPr/>
           </a:p>
         </p:txBody>
       </p:sp>
@@ -17798,7 +17967,7 @@
           <a:noFill/>
         </p:spPr>
         <p:txBody>
-          <a:bodyPr wrap="square" lIns="45720" rIns="45720" tIns="27432" bIns="27432" anchor="t">
+          <a:bodyPr wrap="square" lIns="45720" tIns="27432" rIns="45720" bIns="27432" anchor="t">
             <a:spAutoFit/>
           </a:bodyPr>
           <a:lstStyle/>
@@ -17833,7 +18002,7 @@
           <a:noFill/>
         </p:spPr>
         <p:txBody>
-          <a:bodyPr wrap="square" lIns="45720" rIns="45720" tIns="27432" bIns="27432" anchor="t">
+          <a:bodyPr wrap="square" lIns="45720" tIns="27432" rIns="45720" bIns="27432" anchor="t">
             <a:spAutoFit/>
           </a:bodyPr>
           <a:lstStyle/>
@@ -17893,6 +18062,7 @@
           <a:lstStyle/>
           <a:p>
             <a:pPr algn="ctr"/>
+            <a:endParaRPr/>
           </a:p>
         </p:txBody>
       </p:sp>
@@ -17938,6 +18108,7 @@
           <a:lstStyle/>
           <a:p>
             <a:pPr algn="ctr"/>
+            <a:endParaRPr/>
           </a:p>
         </p:txBody>
       </p:sp>
@@ -17958,7 +18129,7 @@
           <a:noFill/>
         </p:spPr>
         <p:txBody>
-          <a:bodyPr wrap="square" lIns="45720" rIns="45720" tIns="27432" bIns="27432" anchor="t">
+          <a:bodyPr wrap="square" lIns="45720" tIns="27432" rIns="45720" bIns="27432" anchor="t">
             <a:spAutoFit/>
           </a:bodyPr>
           <a:lstStyle/>
@@ -17993,7 +18164,7 @@
           <a:noFill/>
         </p:spPr>
         <p:txBody>
-          <a:bodyPr wrap="square" lIns="45720" rIns="45720" tIns="27432" bIns="27432" anchor="t">
+          <a:bodyPr wrap="square" lIns="45720" tIns="27432" rIns="45720" bIns="27432" anchor="t">
             <a:spAutoFit/>
           </a:bodyPr>
           <a:lstStyle/>
@@ -18053,6 +18224,7 @@
           <a:lstStyle/>
           <a:p>
             <a:pPr algn="ctr"/>
+            <a:endParaRPr/>
           </a:p>
         </p:txBody>
       </p:sp>
@@ -18098,6 +18270,7 @@
           <a:lstStyle/>
           <a:p>
             <a:pPr algn="ctr"/>
+            <a:endParaRPr/>
           </a:p>
         </p:txBody>
       </p:sp>
@@ -18118,7 +18291,7 @@
           <a:noFill/>
         </p:spPr>
         <p:txBody>
-          <a:bodyPr wrap="square" lIns="45720" rIns="45720" tIns="27432" bIns="27432" anchor="t">
+          <a:bodyPr wrap="square" lIns="45720" tIns="27432" rIns="45720" bIns="27432" anchor="t">
             <a:spAutoFit/>
           </a:bodyPr>
           <a:lstStyle/>
@@ -18174,7 +18347,7 @@
           </a:fontRef>
         </p:style>
         <p:txBody>
-          <a:bodyPr rtlCol="0" anchor="ctr" lIns="146304" rIns="146304" tIns="91440" bIns="73152"/>
+          <a:bodyPr lIns="146304" tIns="91440" rIns="146304" bIns="73152" rtlCol="0" anchor="ctr"/>
           <a:lstStyle/>
           <a:p>
             <a:pPr algn="ctr"/>
@@ -18207,7 +18380,7 @@
           <a:noFill/>
         </p:spPr>
         <p:txBody>
-          <a:bodyPr wrap="square" lIns="45720" rIns="45720" tIns="27432" bIns="27432" anchor="t">
+          <a:bodyPr wrap="square" lIns="45720" tIns="27432" rIns="45720" bIns="27432" anchor="t">
             <a:spAutoFit/>
           </a:bodyPr>
           <a:lstStyle/>
@@ -18267,6 +18440,7 @@
           <a:lstStyle/>
           <a:p>
             <a:pPr algn="ctr"/>
+            <a:endParaRPr/>
           </a:p>
         </p:txBody>
       </p:sp>
@@ -18312,6 +18486,7 @@
           <a:lstStyle/>
           <a:p>
             <a:pPr algn="ctr"/>
+            <a:endParaRPr/>
           </a:p>
         </p:txBody>
       </p:sp>
@@ -18332,7 +18507,7 @@
           <a:noFill/>
         </p:spPr>
         <p:txBody>
-          <a:bodyPr wrap="square" lIns="45720" rIns="45720" tIns="27432" bIns="27432" anchor="t">
+          <a:bodyPr wrap="square" lIns="45720" tIns="27432" rIns="45720" bIns="27432" anchor="t">
             <a:spAutoFit/>
           </a:bodyPr>
           <a:lstStyle/>
@@ -18367,7 +18542,7 @@
           <a:noFill/>
         </p:spPr>
         <p:txBody>
-          <a:bodyPr wrap="square" lIns="45720" rIns="45720" tIns="27432" bIns="27432" anchor="t">
+          <a:bodyPr wrap="square" lIns="45720" tIns="27432" rIns="45720" bIns="27432" anchor="t">
             <a:spAutoFit/>
           </a:bodyPr>
           <a:lstStyle/>
@@ -18427,6 +18602,7 @@
           <a:lstStyle/>
           <a:p>
             <a:pPr algn="ctr"/>
+            <a:endParaRPr/>
           </a:p>
         </p:txBody>
       </p:sp>
@@ -18472,6 +18648,7 @@
           <a:lstStyle/>
           <a:p>
             <a:pPr algn="ctr"/>
+            <a:endParaRPr/>
           </a:p>
         </p:txBody>
       </p:sp>
@@ -18492,7 +18669,7 @@
           <a:noFill/>
         </p:spPr>
         <p:txBody>
-          <a:bodyPr wrap="square" lIns="45720" rIns="45720" tIns="27432" bIns="27432" anchor="t">
+          <a:bodyPr wrap="square" lIns="45720" tIns="27432" rIns="45720" bIns="27432" anchor="t">
             <a:spAutoFit/>
           </a:bodyPr>
           <a:lstStyle/>
@@ -18527,7 +18704,7 @@
           <a:noFill/>
         </p:spPr>
         <p:txBody>
-          <a:bodyPr wrap="square" lIns="45720" rIns="45720" tIns="27432" bIns="27432" anchor="t">
+          <a:bodyPr wrap="square" lIns="45720" tIns="27432" rIns="45720" bIns="27432" anchor="t">
             <a:spAutoFit/>
           </a:bodyPr>
           <a:lstStyle/>
@@ -18587,6 +18764,7 @@
           <a:lstStyle/>
           <a:p>
             <a:pPr algn="ctr"/>
+            <a:endParaRPr/>
           </a:p>
         </p:txBody>
       </p:sp>
@@ -18632,6 +18810,7 @@
           <a:lstStyle/>
           <a:p>
             <a:pPr algn="ctr"/>
+            <a:endParaRPr/>
           </a:p>
         </p:txBody>
       </p:sp>
@@ -18652,7 +18831,7 @@
           <a:noFill/>
         </p:spPr>
         <p:txBody>
-          <a:bodyPr wrap="square" lIns="45720" rIns="45720" tIns="27432" bIns="27432" anchor="t">
+          <a:bodyPr wrap="square" lIns="45720" tIns="27432" rIns="45720" bIns="27432" anchor="t">
             <a:spAutoFit/>
           </a:bodyPr>
           <a:lstStyle/>
@@ -18687,7 +18866,7 @@
           <a:noFill/>
         </p:spPr>
         <p:txBody>
-          <a:bodyPr wrap="square" lIns="45720" rIns="45720" tIns="27432" bIns="27432" anchor="t">
+          <a:bodyPr wrap="square" lIns="45720" tIns="27432" rIns="45720" bIns="27432" anchor="t">
             <a:spAutoFit/>
           </a:bodyPr>
           <a:lstStyle/>
@@ -18747,6 +18926,7 @@
           <a:lstStyle/>
           <a:p>
             <a:pPr algn="ctr"/>
+            <a:endParaRPr/>
           </a:p>
         </p:txBody>
       </p:sp>
@@ -18792,6 +18972,7 @@
           <a:lstStyle/>
           <a:p>
             <a:pPr algn="ctr"/>
+            <a:endParaRPr/>
           </a:p>
         </p:txBody>
       </p:sp>
@@ -18812,7 +18993,7 @@
           <a:noFill/>
         </p:spPr>
         <p:txBody>
-          <a:bodyPr wrap="square" lIns="45720" rIns="45720" tIns="27432" bIns="27432" anchor="t">
+          <a:bodyPr wrap="square" lIns="45720" tIns="27432" rIns="45720" bIns="27432" anchor="t">
             <a:spAutoFit/>
           </a:bodyPr>
           <a:lstStyle/>
@@ -18839,7 +19020,7 @@
 </file>
 
 <file path=ppt/slides/slide9.xml><?xml version="1.0" encoding="utf-8"?>
-<p:sld xmlns:a="http://schemas.openxmlformats.org/drawingml/2006/main" xmlns:p="http://schemas.openxmlformats.org/presentationml/2006/main" xmlns:r="http://schemas.openxmlformats.org/officeDocument/2006/relationships">
+<p:sld xmlns:a="http://schemas.openxmlformats.org/drawingml/2006/main" xmlns:r="http://schemas.openxmlformats.org/officeDocument/2006/relationships" xmlns:p="http://schemas.openxmlformats.org/presentationml/2006/main">
   <p:cSld>
     <p:bg>
       <p:bgPr>
@@ -18855,7 +19036,14 @@
         <p:cNvGrpSpPr/>
         <p:nvPr/>
       </p:nvGrpSpPr>
-      <p:grpSpPr/>
+      <p:grpSpPr>
+        <a:xfrm>
+          <a:off x="0" y="0"/>
+          <a:ext cx="0" cy="0"/>
+          <a:chOff x="0" y="0"/>
+          <a:chExt cx="0" cy="0"/>
+        </a:xfrm>
+      </p:grpSpPr>
       <p:sp>
         <p:nvSpPr>
           <p:cNvPr id="2" name="TextBox 1"/>
@@ -18873,7 +19061,7 @@
           <a:noFill/>
         </p:spPr>
         <p:txBody>
-          <a:bodyPr wrap="square" lIns="45720" rIns="45720" tIns="27432" bIns="27432" anchor="t">
+          <a:bodyPr wrap="square" lIns="45720" tIns="27432" rIns="45720" bIns="27432" anchor="t">
             <a:spAutoFit/>
           </a:bodyPr>
           <a:lstStyle/>
@@ -18908,7 +19096,7 @@
           <a:noFill/>
         </p:spPr>
         <p:txBody>
-          <a:bodyPr wrap="square" lIns="45720" rIns="45720" tIns="27432" bIns="27432" anchor="t">
+          <a:bodyPr wrap="square" lIns="45720" tIns="27432" rIns="45720" bIns="27432" anchor="t">
             <a:spAutoFit/>
           </a:bodyPr>
           <a:lstStyle/>
@@ -18947,7 +19135,7 @@
           <a:noFill/>
         </p:spPr>
         <p:txBody>
-          <a:bodyPr wrap="square" lIns="45720" rIns="45720" tIns="27432" bIns="27432" anchor="t">
+          <a:bodyPr wrap="square" lIns="45720" tIns="27432" rIns="45720" bIns="27432" anchor="t">
             <a:spAutoFit/>
           </a:bodyPr>
           <a:lstStyle/>
@@ -19003,7 +19191,7 @@
           </a:fontRef>
         </p:style>
         <p:txBody>
-          <a:bodyPr rtlCol="0" anchor="ctr" lIns="146304" rIns="146304" tIns="91440" bIns="73152"/>
+          <a:bodyPr lIns="146304" tIns="91440" rIns="146304" bIns="73152" rtlCol="0" anchor="ctr"/>
           <a:lstStyle/>
           <a:p>
             <a:pPr algn="ctr"/>
@@ -19073,7 +19261,7 @@
           </a:fontRef>
         </p:style>
         <p:txBody>
-          <a:bodyPr rtlCol="0" anchor="ctr" lIns="146304" rIns="146304" tIns="91440" bIns="73152"/>
+          <a:bodyPr lIns="146304" tIns="91440" rIns="146304" bIns="73152" rtlCol="0" anchor="ctr"/>
           <a:lstStyle/>
           <a:p>
             <a:pPr algn="ctr"/>
@@ -19143,7 +19331,7 @@
           </a:fontRef>
         </p:style>
         <p:txBody>
-          <a:bodyPr rtlCol="0" anchor="ctr" wrap="square" lIns="164592" rIns="164592" tIns="109728" bIns="91440"/>
+          <a:bodyPr wrap="square" lIns="164592" tIns="109728" rIns="164592" bIns="91440" rtlCol="0" anchor="ctr"/>
           <a:lstStyle/>
           <a:p>
             <a:pPr algn="ctr"/>
@@ -19245,7 +19433,7 @@
           </a:fontRef>
         </p:style>
         <p:txBody>
-          <a:bodyPr rtlCol="0" anchor="ctr" wrap="square" lIns="164592" rIns="164592" tIns="109728" bIns="91440"/>
+          <a:bodyPr wrap="square" lIns="164592" tIns="109728" rIns="164592" bIns="91440" rtlCol="0" anchor="ctr"/>
           <a:lstStyle/>
           <a:p>
             <a:pPr algn="ctr"/>
@@ -19347,7 +19535,7 @@
           </a:fontRef>
         </p:style>
         <p:txBody>
-          <a:bodyPr rtlCol="0" anchor="ctr" wrap="square" lIns="164592" rIns="164592" tIns="109728" bIns="91440"/>
+          <a:bodyPr wrap="square" lIns="164592" tIns="109728" rIns="164592" bIns="91440" rtlCol="0" anchor="ctr"/>
           <a:lstStyle/>
           <a:p>
             <a:pPr algn="ctr"/>

</xml_diff>

<commit_message>
Add pasted figure screenshots to PubMed PPTX
</commit_message>
<xml_diff>
--- a/archive/2026-06-02/pubmed-dlbcl-cnsl-btki-2026-06-02.pptx
+++ b/archive/2026-06-02/pubmed-dlbcl-cnsl-btki-2026-06-02.pptx
@@ -4875,6 +4875,30 @@
           </a:p>
         </p:txBody>
       </p:sp>
+      <p:pic>
+        <p:nvPicPr>
+          <p:cNvPr id="33" name="Picture 32" descr="slide-010.png"/>
+          <p:cNvPicPr>
+            <a:picLocks noChangeAspect="1"/>
+          </p:cNvPicPr>
+          <p:nvPr/>
+        </p:nvPicPr>
+        <p:blipFill>
+          <a:blip r:embed="rId2"/>
+          <a:stretch>
+            <a:fillRect/>
+          </a:stretch>
+        </p:blipFill>
+        <p:spPr>
+          <a:xfrm>
+            <a:off x="0" y="0"/>
+            <a:ext cx="12191695" cy="6858000"/>
+          </a:xfrm>
+          <a:prstGeom prst="rect">
+            <a:avLst/>
+          </a:prstGeom>
+        </p:spPr>
+      </p:pic>
     </p:spTree>
   </p:cSld>
   <p:clrMapOvr>
@@ -6811,6 +6835,30 @@
           </a:p>
         </p:txBody>
       </p:sp>
+      <p:pic>
+        <p:nvPicPr>
+          <p:cNvPr id="33" name="Picture 32" descr="slide-012.png"/>
+          <p:cNvPicPr>
+            <a:picLocks noChangeAspect="1"/>
+          </p:cNvPicPr>
+          <p:nvPr/>
+        </p:nvPicPr>
+        <p:blipFill>
+          <a:blip r:embed="rId2"/>
+          <a:stretch>
+            <a:fillRect/>
+          </a:stretch>
+        </p:blipFill>
+        <p:spPr>
+          <a:xfrm>
+            <a:off x="0" y="0"/>
+            <a:ext cx="12191695" cy="6858000"/>
+          </a:xfrm>
+          <a:prstGeom prst="rect">
+            <a:avLst/>
+          </a:prstGeom>
+        </p:spPr>
+      </p:pic>
     </p:spTree>
   </p:cSld>
   <p:clrMapOvr>
@@ -9217,6 +9265,30 @@
           </a:p>
         </p:txBody>
       </p:sp>
+      <p:pic>
+        <p:nvPicPr>
+          <p:cNvPr id="45" name="Picture 44" descr="slide-014.png"/>
+          <p:cNvPicPr>
+            <a:picLocks noChangeAspect="1"/>
+          </p:cNvPicPr>
+          <p:nvPr/>
+        </p:nvPicPr>
+        <p:blipFill>
+          <a:blip r:embed="rId2"/>
+          <a:stretch>
+            <a:fillRect/>
+          </a:stretch>
+        </p:blipFill>
+        <p:spPr>
+          <a:xfrm>
+            <a:off x="0" y="0"/>
+            <a:ext cx="12191695" cy="6858000"/>
+          </a:xfrm>
+          <a:prstGeom prst="rect">
+            <a:avLst/>
+          </a:prstGeom>
+        </p:spPr>
+      </p:pic>
     </p:spTree>
   </p:cSld>
   <p:clrMapOvr>
@@ -12054,6 +12126,30 @@
           </a:p>
         </p:txBody>
       </p:sp>
+      <p:pic>
+        <p:nvPicPr>
+          <p:cNvPr id="41" name="Picture 40" descr="slide-003.png"/>
+          <p:cNvPicPr>
+            <a:picLocks noChangeAspect="1"/>
+          </p:cNvPicPr>
+          <p:nvPr/>
+        </p:nvPicPr>
+        <p:blipFill>
+          <a:blip r:embed="rId2"/>
+          <a:stretch>
+            <a:fillRect/>
+          </a:stretch>
+        </p:blipFill>
+        <p:spPr>
+          <a:xfrm>
+            <a:off x="0" y="0"/>
+            <a:ext cx="12191695" cy="6858000"/>
+          </a:xfrm>
+          <a:prstGeom prst="rect">
+            <a:avLst/>
+          </a:prstGeom>
+        </p:spPr>
+      </p:pic>
     </p:spTree>
   </p:cSld>
   <p:clrMapOvr>
@@ -13962,6 +14058,30 @@
           </a:p>
         </p:txBody>
       </p:sp>
+      <p:pic>
+        <p:nvPicPr>
+          <p:cNvPr id="48" name="Picture 47" descr="slide-004.png"/>
+          <p:cNvPicPr>
+            <a:picLocks noChangeAspect="1"/>
+          </p:cNvPicPr>
+          <p:nvPr/>
+        </p:nvPicPr>
+        <p:blipFill>
+          <a:blip r:embed="rId2"/>
+          <a:stretch>
+            <a:fillRect/>
+          </a:stretch>
+        </p:blipFill>
+        <p:spPr>
+          <a:xfrm>
+            <a:off x="0" y="0"/>
+            <a:ext cx="12191695" cy="6858000"/>
+          </a:xfrm>
+          <a:prstGeom prst="rect">
+            <a:avLst/>
+          </a:prstGeom>
+        </p:spPr>
+      </p:pic>
     </p:spTree>
   </p:cSld>
   <p:clrMapOvr>
@@ -16530,6 +16650,30 @@
           </a:p>
         </p:txBody>
       </p:sp>
+      <p:pic>
+        <p:nvPicPr>
+          <p:cNvPr id="49" name="Picture 48" descr="slide-006.png"/>
+          <p:cNvPicPr>
+            <a:picLocks noChangeAspect="1"/>
+          </p:cNvPicPr>
+          <p:nvPr/>
+        </p:nvPicPr>
+        <p:blipFill>
+          <a:blip r:embed="rId2"/>
+          <a:stretch>
+            <a:fillRect/>
+          </a:stretch>
+        </p:blipFill>
+        <p:spPr>
+          <a:xfrm>
+            <a:off x="0" y="0"/>
+            <a:ext cx="12191695" cy="6858000"/>
+          </a:xfrm>
+          <a:prstGeom prst="rect">
+            <a:avLst/>
+          </a:prstGeom>
+        </p:spPr>
+      </p:pic>
     </p:spTree>
   </p:cSld>
   <p:clrMapOvr>
@@ -18936,6 +19080,30 @@
           </a:p>
         </p:txBody>
       </p:sp>
+      <p:pic>
+        <p:nvPicPr>
+          <p:cNvPr id="45" name="Picture 44" descr="slide-008.png"/>
+          <p:cNvPicPr>
+            <a:picLocks noChangeAspect="1"/>
+          </p:cNvPicPr>
+          <p:nvPr/>
+        </p:nvPicPr>
+        <p:blipFill>
+          <a:blip r:embed="rId2"/>
+          <a:stretch>
+            <a:fillRect/>
+          </a:stretch>
+        </p:blipFill>
+        <p:spPr>
+          <a:xfrm>
+            <a:off x="0" y="0"/>
+            <a:ext cx="12191695" cy="6858000"/>
+          </a:xfrm>
+          <a:prstGeom prst="rect">
+            <a:avLst/>
+          </a:prstGeom>
+        </p:spPr>
+      </p:pic>
     </p:spTree>
   </p:cSld>
   <p:clrMapOvr>

</xml_diff>